<commit_message>
docs(informe): fusiona ediciones locales (nombres, capturas) con el contenido de Alexandra sobre el cliente C#
</commit_message>
<xml_diff>
--- a/informe/presentacion_soap.pptx
+++ b/informe/presentacion_soap.pptx
@@ -4,6 +4,9 @@
   <p:sldMasterIdLst>
     <p:sldMasterId id="2147483648" r:id="rId1"/>
   </p:sldMasterIdLst>
+  <p:notesMasterIdLst>
+    <p:notesMasterId r:id="rId18"/>
+  </p:notesMasterIdLst>
   <p:sldIdLst>
     <p:sldId id="256" r:id="rId2"/>
     <p:sldId id="257" r:id="rId3"/>
@@ -22,9 +25,6 @@
     <p:sldId id="270" r:id="rId16"/>
     <p:sldId id="271" r:id="rId17"/>
   </p:sldIdLst>
-  <p:notesMasterIdLst>
-    <p:notesMasterId r:id="rId18"/>
-  </p:notesMasterIdLst>
   <p:sldSz cx="12192000" cy="6858000"/>
   <p:notesSz cx="6858000" cy="12192000"/>
   <p:defaultTextStyle>
@@ -119,6 +119,11 @@
       </a:defRPr>
     </a:lvl9pPr>
   </p:defaultTextStyle>
+  <p:extLst>
+    <p:ext uri="{EFAFB233-063F-42B5-8137-9DF3F51BA10A}">
+      <p15:sldGuideLst xmlns:p15="http://schemas.microsoft.com/office/powerpoint/2012/main"/>
+    </p:ext>
+  </p:extLst>
 </p:presentation>
 </file>
 
@@ -144,234 +149,10 @@
           <a:chExt cx="0" cy="0"/>
         </a:xfrm>
       </p:grpSpPr>
-      <p:sp>
-        <p:nvSpPr>
-          <p:cNvPr id="2" name="Header Placeholder 1"/>
-          <p:cNvSpPr>
-            <a:spLocks noGrp="1"/>
-          </p:cNvSpPr>
-          <p:nvPr>
-            <p:ph type="hdr" sz="quarter"/>
-          </p:nvPr>
-        </p:nvSpPr>
-        <p:spPr>
-          <a:xfrm>
-            <a:off x="0" y="0"/>
-            <a:ext cx="2971800" cy="458788"/>
-          </a:xfrm>
-          <a:prstGeom prst="rect">
-            <a:avLst/>
-          </a:prstGeom>
-        </p:spPr>
-        <p:txBody>
-          <a:bodyPr vert="horz" lIns="91440" tIns="45720" rIns="91440" bIns="45720" rtlCol="0"/>
-          <a:lstStyle>
-            <a:lvl1pPr algn="l">
-              <a:defRPr sz="1200"/>
-            </a:lvl1pPr>
-          </a:lstStyle>
-          <a:p>
-            <a:endParaRPr lang="en-US"/>
-          </a:p>
-        </p:txBody>
-      </p:sp>
-      <p:sp>
-        <p:nvSpPr>
-          <p:cNvPr id="3" name="Date Placeholder 2"/>
-          <p:cNvSpPr>
-            <a:spLocks noGrp="1"/>
-          </p:cNvSpPr>
-          <p:nvPr>
-            <p:ph type="dt" idx="1"/>
-          </p:nvPr>
-        </p:nvSpPr>
-        <p:spPr>
-          <a:xfrm>
-            <a:off x="3884613" y="0"/>
-            <a:ext cx="2971800" cy="458788"/>
-          </a:xfrm>
-          <a:prstGeom prst="rect">
-            <a:avLst/>
-          </a:prstGeom>
-        </p:spPr>
-        <p:txBody>
-          <a:bodyPr vert="horz" lIns="91440" tIns="45720" rIns="91440" bIns="45720" rtlCol="0"/>
-          <a:lstStyle>
-            <a:lvl1pPr algn="r">
-              <a:defRPr sz="1200"/>
-            </a:lvl1pPr>
-          </a:lstStyle>
-          <a:p>
-            <a:fld id="{5282F153-3F37-0F45-9E97-73ACFA13230C}" type="datetimeFigureOut">
-              <a:rPr lang="en-US"/>
-              <a:t>7/23/19</a:t>
-            </a:fld>
-            <a:endParaRPr lang="en-US"/>
-          </a:p>
-        </p:txBody>
-      </p:sp>
-      <p:sp>
-        <p:nvSpPr>
-          <p:cNvPr id="4" name="Slide Image Placeholder 3"/>
-          <p:cNvSpPr>
-            <a:spLocks noGrp="1" noRot="1" noChangeAspect="1"/>
-          </p:cNvSpPr>
-          <p:nvPr>
-            <p:ph type="sldImg" idx="2"/>
-          </p:nvPr>
-        </p:nvSpPr>
-        <p:spPr>
-          <a:xfrm>
-            <a:off x="685800" y="1143000"/>
-            <a:ext cx="5486400" cy="3086100"/>
-          </a:xfrm>
-          <a:prstGeom prst="rect">
-            <a:avLst/>
-          </a:prstGeom>
-          <a:noFill/>
-          <a:ln w="12700">
-            <a:solidFill>
-              <a:prstClr val="black"/>
-            </a:solidFill>
-          </a:ln>
-        </p:spPr>
-        <p:txBody>
-          <a:bodyPr vert="horz" lIns="91440" tIns="45720" rIns="91440" bIns="45720" rtlCol="0" anchor="ctr"/>
-          <a:lstStyle/>
-          <a:p>
-            <a:endParaRPr lang="en-US"/>
-          </a:p>
-        </p:txBody>
-      </p:sp>
-      <p:sp>
-        <p:nvSpPr>
-          <p:cNvPr id="5" name="Notes Placeholder 4"/>
-          <p:cNvSpPr>
-            <a:spLocks noGrp="1"/>
-          </p:cNvSpPr>
-          <p:nvPr>
-            <p:ph type="body" sz="quarter" idx="3"/>
-          </p:nvPr>
-        </p:nvSpPr>
-        <p:spPr>
-          <a:xfrm>
-            <a:off x="685800" y="4400550"/>
-            <a:ext cx="5486400" cy="3600450"/>
-          </a:xfrm>
-          <a:prstGeom prst="rect">
-            <a:avLst/>
-          </a:prstGeom>
-        </p:spPr>
-        <p:txBody>
-          <a:bodyPr vert="horz" lIns="91440" tIns="45720" rIns="91440" bIns="45720" rtlCol="0"/>
-          <a:lstStyle/>
-          <a:p>
-            <a:pPr lvl="0"/>
-            <a:r>
-              <a:rPr lang="en-US"/>
-              <a:t>Click to edit Master text styles</a:t>
-            </a:r>
-          </a:p>
-          <a:p>
-            <a:pPr lvl="1"/>
-            <a:r>
-              <a:rPr lang="en-US"/>
-              <a:t>Second level</a:t>
-            </a:r>
-          </a:p>
-          <a:p>
-            <a:pPr lvl="2"/>
-            <a:r>
-              <a:rPr lang="en-US"/>
-              <a:t>Third level</a:t>
-            </a:r>
-          </a:p>
-          <a:p>
-            <a:pPr lvl="3"/>
-            <a:r>
-              <a:rPr lang="en-US"/>
-              <a:t>Fourth level</a:t>
-            </a:r>
-          </a:p>
-          <a:p>
-            <a:pPr lvl="4"/>
-            <a:r>
-              <a:rPr lang="en-US"/>
-              <a:t>Fifth level</a:t>
-            </a:r>
-          </a:p>
-        </p:txBody>
-      </p:sp>
-      <p:sp>
-        <p:nvSpPr>
-          <p:cNvPr id="6" name="Footer Placeholder 5"/>
-          <p:cNvSpPr>
-            <a:spLocks noGrp="1"/>
-          </p:cNvSpPr>
-          <p:nvPr>
-            <p:ph type="ftr" sz="quarter" idx="4"/>
-          </p:nvPr>
-        </p:nvSpPr>
-        <p:spPr>
-          <a:xfrm>
-            <a:off x="0" y="8685213"/>
-            <a:ext cx="2971800" cy="458787"/>
-          </a:xfrm>
-          <a:prstGeom prst="rect">
-            <a:avLst/>
-          </a:prstGeom>
-        </p:spPr>
-        <p:txBody>
-          <a:bodyPr vert="horz" lIns="91440" tIns="45720" rIns="91440" bIns="45720" rtlCol="0" anchor="b"/>
-          <a:lstStyle>
-            <a:lvl1pPr algn="l">
-              <a:defRPr sz="1200"/>
-            </a:lvl1pPr>
-          </a:lstStyle>
-          <a:p>
-            <a:endParaRPr lang="en-US"/>
-          </a:p>
-        </p:txBody>
-      </p:sp>
-      <p:sp>
-        <p:nvSpPr>
-          <p:cNvPr id="7" name="Slide Number Placeholder 6"/>
-          <p:cNvSpPr>
-            <a:spLocks noGrp="1"/>
-          </p:cNvSpPr>
-          <p:nvPr>
-            <p:ph type="sldNum" sz="quarter" idx="5"/>
-          </p:nvPr>
-        </p:nvSpPr>
-        <p:spPr>
-          <a:xfrm>
-            <a:off x="3884613" y="8685213"/>
-            <a:ext cx="2971800" cy="458787"/>
-          </a:xfrm>
-          <a:prstGeom prst="rect">
-            <a:avLst/>
-          </a:prstGeom>
-        </p:spPr>
-        <p:txBody>
-          <a:bodyPr vert="horz" lIns="91440" tIns="45720" rIns="91440" bIns="45720" rtlCol="0" anchor="b"/>
-          <a:lstStyle>
-            <a:lvl1pPr algn="r">
-              <a:defRPr sz="1200"/>
-            </a:lvl1pPr>
-          </a:lstStyle>
-          <a:p>
-            <a:fld id="{CE5E9CC1-C706-0F49-92D6-E571CC5EEA8F}" type="slidenum">
-              <a:rPr lang="en-US"/>
-              <a:t>‹#›</a:t>
-            </a:fld>
-            <a:endParaRPr lang="en-US"/>
-          </a:p>
-        </p:txBody>
-      </p:sp>
     </p:spTree>
     <p:extLst>
       <p:ext uri="{BB962C8B-B14F-4D97-AF65-F5344CB8AC3E}">
-        <p14:creationId xmlns:p14="http://schemas.microsoft.com/office/powerpoint/2010/main" val="1024086991"/>
+        <p14:creationId xmlns:p14="http://schemas.microsoft.com/office/powerpoint/2010/main" val="3232205039"/>
       </p:ext>
     </p:extLst>
   </p:cSld>
@@ -515,10 +296,6 @@
           <a:bodyPr/>
           <a:lstStyle/>
           <a:p>
-            <a:r>
-              <a:rPr lang="en-US" dirty="0"/>
-              <a:t/>
-            </a:r>
             <a:endParaRPr lang="en-US" dirty="0"/>
           </a:p>
         </p:txBody>
@@ -603,10 +380,6 @@
           <a:bodyPr/>
           <a:lstStyle/>
           <a:p>
-            <a:r>
-              <a:rPr lang="en-US" dirty="0"/>
-              <a:t/>
-            </a:r>
             <a:endParaRPr lang="en-US" dirty="0"/>
           </a:p>
         </p:txBody>
@@ -691,10 +464,6 @@
           <a:bodyPr/>
           <a:lstStyle/>
           <a:p>
-            <a:r>
-              <a:rPr lang="en-US" dirty="0"/>
-              <a:t/>
-            </a:r>
             <a:endParaRPr lang="en-US" dirty="0"/>
           </a:p>
         </p:txBody>
@@ -779,10 +548,6 @@
           <a:bodyPr/>
           <a:lstStyle/>
           <a:p>
-            <a:r>
-              <a:rPr lang="en-US" dirty="0"/>
-              <a:t/>
-            </a:r>
             <a:endParaRPr lang="en-US" dirty="0"/>
           </a:p>
         </p:txBody>
@@ -867,10 +632,6 @@
           <a:bodyPr/>
           <a:lstStyle/>
           <a:p>
-            <a:r>
-              <a:rPr lang="en-US" dirty="0"/>
-              <a:t/>
-            </a:r>
             <a:endParaRPr lang="en-US" dirty="0"/>
           </a:p>
         </p:txBody>
@@ -955,10 +716,6 @@
           <a:bodyPr/>
           <a:lstStyle/>
           <a:p>
-            <a:r>
-              <a:rPr lang="en-US" dirty="0"/>
-              <a:t/>
-            </a:r>
             <a:endParaRPr lang="en-US" dirty="0"/>
           </a:p>
         </p:txBody>
@@ -1043,10 +800,6 @@
           <a:bodyPr/>
           <a:lstStyle/>
           <a:p>
-            <a:r>
-              <a:rPr lang="en-US" dirty="0"/>
-              <a:t/>
-            </a:r>
             <a:endParaRPr lang="en-US" dirty="0"/>
           </a:p>
         </p:txBody>
@@ -1131,10 +884,6 @@
           <a:bodyPr/>
           <a:lstStyle/>
           <a:p>
-            <a:r>
-              <a:rPr lang="en-US" dirty="0"/>
-              <a:t/>
-            </a:r>
             <a:endParaRPr lang="en-US" dirty="0"/>
           </a:p>
         </p:txBody>
@@ -1219,10 +968,6 @@
           <a:bodyPr/>
           <a:lstStyle/>
           <a:p>
-            <a:r>
-              <a:rPr lang="en-US" dirty="0"/>
-              <a:t/>
-            </a:r>
             <a:endParaRPr lang="en-US" dirty="0"/>
           </a:p>
         </p:txBody>
@@ -1307,10 +1052,6 @@
           <a:bodyPr/>
           <a:lstStyle/>
           <a:p>
-            <a:r>
-              <a:rPr lang="en-US" dirty="0"/>
-              <a:t/>
-            </a:r>
             <a:endParaRPr lang="en-US" dirty="0"/>
           </a:p>
         </p:txBody>
@@ -1395,10 +1136,6 @@
           <a:bodyPr/>
           <a:lstStyle/>
           <a:p>
-            <a:r>
-              <a:rPr lang="en-US" dirty="0"/>
-              <a:t/>
-            </a:r>
             <a:endParaRPr lang="en-US" dirty="0"/>
           </a:p>
         </p:txBody>
@@ -1483,10 +1220,6 @@
           <a:bodyPr/>
           <a:lstStyle/>
           <a:p>
-            <a:r>
-              <a:rPr lang="en-US" dirty="0"/>
-              <a:t/>
-            </a:r>
             <a:endParaRPr lang="en-US" dirty="0"/>
           </a:p>
         </p:txBody>
@@ -1571,10 +1304,6 @@
           <a:bodyPr/>
           <a:lstStyle/>
           <a:p>
-            <a:r>
-              <a:rPr lang="en-US" dirty="0"/>
-              <a:t/>
-            </a:r>
             <a:endParaRPr lang="en-US" dirty="0"/>
           </a:p>
         </p:txBody>
@@ -1659,10 +1388,6 @@
           <a:bodyPr/>
           <a:lstStyle/>
           <a:p>
-            <a:r>
-              <a:rPr lang="en-US" dirty="0"/>
-              <a:t/>
-            </a:r>
             <a:endParaRPr lang="en-US" dirty="0"/>
           </a:p>
         </p:txBody>
@@ -1747,10 +1472,6 @@
           <a:bodyPr/>
           <a:lstStyle/>
           <a:p>
-            <a:r>
-              <a:rPr lang="en-US" dirty="0"/>
-              <a:t/>
-            </a:r>
             <a:endParaRPr lang="en-US" dirty="0"/>
           </a:p>
         </p:txBody>
@@ -1835,10 +1556,6 @@
           <a:bodyPr/>
           <a:lstStyle/>
           <a:p>
-            <a:r>
-              <a:rPr lang="en-US" dirty="0"/>
-              <a:t/>
-            </a:r>
             <a:endParaRPr lang="en-US" dirty="0"/>
           </a:p>
         </p:txBody>
@@ -1912,6 +1629,11 @@
 <file path=ppt/slideMasters/slideMaster1.xml><?xml version="1.0" encoding="utf-8"?>
 <p:sldMaster xmlns:a="http://schemas.openxmlformats.org/drawingml/2006/main" xmlns:r="http://schemas.openxmlformats.org/officeDocument/2006/relationships" xmlns:p="http://schemas.openxmlformats.org/presentationml/2006/main">
   <p:cSld>
+    <p:bg>
+      <p:bgRef idx="1001">
+        <a:schemeClr val="bg1"/>
+      </p:bgRef>
+    </p:bg>
     <p:spTree>
       <p:nvGrpSpPr>
         <p:cNvPr id="1" name=""/>
@@ -2194,6 +1916,7 @@
         <a:solidFill>
           <a:srgbClr val="16211D"/>
         </a:solidFill>
+        <a:effectLst/>
       </p:bgPr>
     </p:bg>
     <p:spTree>
@@ -2212,7 +1935,9 @@
       </p:grpSpPr>
       <p:sp>
         <p:nvSpPr>
-          <p:cNvPr id="2" name="Shape 0"/>
+          <p:cNvPr id="2" name="Shape 0">
+            <a:hlinkClick r:id="rId3"/>
+          </p:cNvPr>
           <p:cNvSpPr/>
           <p:nvPr/>
         </p:nvSpPr>
@@ -2229,6 +1954,13 @@
           </a:solidFill>
           <a:ln/>
         </p:spPr>
+        <p:txBody>
+          <a:bodyPr/>
+          <a:lstStyle/>
+          <a:p>
+            <a:endParaRPr lang="es-ES"/>
+          </a:p>
+        </p:txBody>
       </p:sp>
       <p:sp>
         <p:nvSpPr>
@@ -2249,6 +1981,13 @@
           </a:solidFill>
           <a:ln/>
         </p:spPr>
+        <p:txBody>
+          <a:bodyPr/>
+          <a:lstStyle/>
+          <a:p>
+            <a:endParaRPr lang="es-ES"/>
+          </a:p>
+        </p:txBody>
       </p:sp>
       <p:sp>
         <p:nvSpPr>
@@ -2271,7 +2010,7 @@
           <a:bodyPr wrap="square" lIns="0" tIns="0" rIns="0" bIns="0" rtlCol="0" anchor="ctr"/>
           <a:lstStyle/>
           <a:p>
-            <a:pPr algn="ctr" indent="0" marL="0">
+            <a:pPr marL="0" indent="0" algn="ctr">
               <a:buNone/>
             </a:pPr>
             <a:r>
@@ -2310,11 +2049,11 @@
           <a:bodyPr wrap="square" lIns="0" tIns="0" rIns="0" bIns="0" rtlCol="0" anchor="ctr"/>
           <a:lstStyle/>
           <a:p>
-            <a:pPr indent="0" marL="0">
-              <a:buNone/>
-            </a:pPr>
-            <a:r>
-              <a:rPr lang="en-US" sz="1300" b="1" spc="200" kern="0" dirty="0">
+            <a:pPr marL="0" indent="0">
+              <a:buNone/>
+            </a:pPr>
+            <a:r>
+              <a:rPr lang="en-US" sz="1300" b="1" kern="0" spc="200" dirty="0">
                 <a:solidFill>
                   <a:srgbClr val="8FD6B8"/>
                 </a:solidFill>
@@ -2349,7 +2088,7 @@
           <a:bodyPr wrap="square" lIns="0" tIns="0" rIns="0" bIns="0" rtlCol="0" anchor="ctr"/>
           <a:lstStyle/>
           <a:p>
-            <a:pPr indent="0" marL="0">
+            <a:pPr marL="0" indent="0">
               <a:lnSpc>
                 <a:spcPts val="5000"/>
               </a:lnSpc>
@@ -2369,7 +2108,7 @@
             <a:endParaRPr lang="en-US" sz="4400" dirty="0"/>
           </a:p>
           <a:p>
-            <a:pPr indent="0" marL="0">
+            <a:pPr marL="0" indent="0">
               <a:lnSpc>
                 <a:spcPts val="5000"/>
               </a:lnSpc>
@@ -2411,7 +2150,7 @@
           <a:bodyPr wrap="square" lIns="0" tIns="0" rIns="0" bIns="0" rtlCol="0" anchor="ctr"/>
           <a:lstStyle/>
           <a:p>
-            <a:pPr indent="0" marL="0">
+            <a:pPr marL="0" indent="0">
               <a:buNone/>
             </a:pPr>
             <a:r>
@@ -2451,6 +2190,13 @@
             <a:prstDash val="solid"/>
           </a:ln>
         </p:spPr>
+        <p:txBody>
+          <a:bodyPr/>
+          <a:lstStyle/>
+          <a:p>
+            <a:endParaRPr lang="es-ES"/>
+          </a:p>
+        </p:txBody>
       </p:sp>
       <p:sp>
         <p:nvSpPr>
@@ -2473,7 +2219,7 @@
           <a:bodyPr wrap="square" lIns="0" tIns="0" rIns="0" bIns="0" rtlCol="0" anchor="ctr"/>
           <a:lstStyle/>
           <a:p>
-            <a:pPr indent="0" marL="0">
+            <a:pPr marL="0" indent="0">
               <a:buNone/>
             </a:pPr>
             <a:r>
@@ -2512,7 +2258,7 @@
           <a:bodyPr wrap="square" lIns="0" tIns="0" rIns="0" bIns="0" rtlCol="0" anchor="ctr"/>
           <a:lstStyle/>
           <a:p>
-            <a:pPr indent="0" marL="0">
+            <a:pPr marL="0" indent="0">
               <a:buNone/>
             </a:pPr>
             <a:r>
@@ -2527,6 +2273,63 @@
               <a:t>Ismael Vanegas   ·   Alexandra Caicedo   ·   Israel Arevalo</a:t>
             </a:r>
             <a:endParaRPr lang="en-US" sz="1400" dirty="0"/>
+          </a:p>
+        </p:txBody>
+      </p:sp>
+      <p:sp>
+        <p:nvSpPr>
+          <p:cNvPr id="11" name="Text 3">
+            <a:extLst>
+              <a:ext uri="{FF2B5EF4-FFF2-40B4-BE49-F238E27FC236}">
+                <a16:creationId xmlns:a16="http://schemas.microsoft.com/office/drawing/2014/main" id="{82FCD4C8-8415-32C9-3907-47C6F865C781}"/>
+              </a:ext>
+            </a:extLst>
+          </p:cNvPr>
+          <p:cNvSpPr/>
+          <p:nvPr/>
+        </p:nvSpPr>
+        <p:spPr>
+          <a:xfrm>
+            <a:off x="9807191" y="6036061"/>
+            <a:ext cx="1788607" cy="457200"/>
+          </a:xfrm>
+          <a:prstGeom prst="rect">
+            <a:avLst/>
+          </a:prstGeom>
+          <a:noFill/>
+          <a:ln/>
+        </p:spPr>
+        <p:txBody>
+          <a:bodyPr wrap="square" lIns="0" tIns="0" rIns="0" bIns="0" rtlCol="0" anchor="ctr"/>
+          <a:lstStyle/>
+          <a:p>
+            <a:pPr marL="0" indent="0">
+              <a:buNone/>
+            </a:pPr>
+            <a:r>
+              <a:rPr lang="en-US" b="1" kern="0" spc="200" dirty="0">
+                <a:solidFill>
+                  <a:srgbClr val="8FD6B8"/>
+                </a:solidFill>
+                <a:latin typeface="Calibri" pitchFamily="34" charset="0"/>
+                <a:ea typeface="Calibri" pitchFamily="34" charset="-122"/>
+                <a:cs typeface="Calibri" pitchFamily="34" charset="-120"/>
+              </a:rPr>
+              <a:t>Link: </a:t>
+            </a:r>
+            <a:r>
+              <a:rPr lang="en-US" b="1" kern="0" spc="200" dirty="0">
+                <a:solidFill>
+                  <a:srgbClr val="8FD6B8"/>
+                </a:solidFill>
+                <a:latin typeface="Calibri" pitchFamily="34" charset="0"/>
+                <a:ea typeface="Calibri" pitchFamily="34" charset="-122"/>
+                <a:cs typeface="Calibri" pitchFamily="34" charset="-120"/>
+                <a:hlinkClick r:id="rId3"/>
+              </a:rPr>
+              <a:t>GitHub</a:t>
+            </a:r>
+            <a:endParaRPr lang="en-US" dirty="0"/>
           </a:p>
         </p:txBody>
       </p:sp>
@@ -2546,6 +2349,7 @@
         <a:solidFill>
           <a:srgbClr val="F7F8F5"/>
         </a:solidFill>
+        <a:effectLst/>
       </p:bgPr>
     </p:bg>
     <p:spTree>
@@ -2583,11 +2387,11 @@
           <a:bodyPr wrap="square" lIns="0" tIns="0" rIns="0" bIns="0" rtlCol="0" anchor="ctr"/>
           <a:lstStyle/>
           <a:p>
-            <a:pPr indent="0" marL="0">
-              <a:buNone/>
-            </a:pPr>
-            <a:r>
-              <a:rPr lang="en-US" sz="1200" b="1" spc="200" kern="0" dirty="0">
+            <a:pPr marL="0" indent="0">
+              <a:buNone/>
+            </a:pPr>
+            <a:r>
+              <a:rPr lang="en-US" sz="1200" b="1" kern="0" spc="200" dirty="0">
                 <a:solidFill>
                   <a:srgbClr val="2F6F5E"/>
                 </a:solidFill>
@@ -2622,7 +2426,7 @@
           <a:bodyPr wrap="square" lIns="0" tIns="0" rIns="0" bIns="0" rtlCol="0" anchor="ctr"/>
           <a:lstStyle/>
           <a:p>
-            <a:pPr indent="0" marL="0">
+            <a:pPr marL="0" indent="0">
               <a:buNone/>
             </a:pPr>
             <a:r>
@@ -2661,7 +2465,7 @@
           <a:bodyPr wrap="square" lIns="0" tIns="0" rIns="0" bIns="0" rtlCol="0" anchor="ctr"/>
           <a:lstStyle/>
           <a:p>
-            <a:pPr indent="0" marL="0">
+            <a:pPr marL="0" indent="0">
               <a:buNone/>
             </a:pPr>
             <a:r>
@@ -2700,17 +2504,24 @@
           </a:solidFill>
           <a:ln/>
         </p:spPr>
+        <p:txBody>
+          <a:bodyPr/>
+          <a:lstStyle/>
+          <a:p>
+            <a:endParaRPr lang="es-ES"/>
+          </a:p>
+        </p:txBody>
       </p:sp>
       <p:pic>
         <p:nvPicPr>
-          <p:cNvPr id="6" name="Image 0" descr="C:\Users\melpe\AppData\Local\Temp\claude\D--Ismael-DESARROLLO-lumio-notas-proyecto-claude\2a3cac32-8aea-4b5c-8de5-c2c7e1550d08\scratchpad\ppt_assets\docx_media\word\media\image10.png">    </p:cNvPr>
+          <p:cNvPr id="6" name="Image 0" descr="C:\Users\melpe\AppData\Local\Temp\claude\D--Ismael-DESARROLLO-lumio-notas-proyecto-claude\2a3cac32-8aea-4b5c-8de5-c2c7e1550d08\scratchpad\ppt_assets\docx_media\word\media\image10.png"/>
           <p:cNvPicPr>
             <a:picLocks noChangeAspect="1"/>
           </p:cNvPicPr>
           <p:nvPr/>
         </p:nvPicPr>
         <p:blipFill>
-          <a:blip r:embed="rId1"/>
+          <a:blip r:embed="rId3"/>
           <a:stretch>
             <a:fillRect/>
           </a:stretch>
@@ -2746,7 +2557,7 @@
           <a:bodyPr wrap="square" lIns="0" tIns="0" rIns="0" bIns="0" rtlCol="0" anchor="ctr"/>
           <a:lstStyle/>
           <a:p>
-            <a:pPr algn="r" indent="0" marL="0">
+            <a:pPr marL="0" indent="0" algn="r">
               <a:buNone/>
             </a:pPr>
             <a:r>
@@ -2761,6 +2572,63 @@
               <a:t>10</a:t>
             </a:r>
             <a:endParaRPr lang="en-US" sz="1000" dirty="0"/>
+          </a:p>
+        </p:txBody>
+      </p:sp>
+      <p:sp>
+        <p:nvSpPr>
+          <p:cNvPr id="8" name="Text 3">
+            <a:extLst>
+              <a:ext uri="{FF2B5EF4-FFF2-40B4-BE49-F238E27FC236}">
+                <a16:creationId xmlns:a16="http://schemas.microsoft.com/office/drawing/2014/main" id="{4528426F-25FA-5E41-2578-626771717956}"/>
+              </a:ext>
+            </a:extLst>
+          </p:cNvPr>
+          <p:cNvSpPr/>
+          <p:nvPr/>
+        </p:nvSpPr>
+        <p:spPr>
+          <a:xfrm>
+            <a:off x="9807191" y="6036061"/>
+            <a:ext cx="1788607" cy="457200"/>
+          </a:xfrm>
+          <a:prstGeom prst="rect">
+            <a:avLst/>
+          </a:prstGeom>
+          <a:noFill/>
+          <a:ln/>
+        </p:spPr>
+        <p:txBody>
+          <a:bodyPr wrap="square" lIns="0" tIns="0" rIns="0" bIns="0" rtlCol="0" anchor="ctr"/>
+          <a:lstStyle/>
+          <a:p>
+            <a:pPr marL="0" indent="0">
+              <a:buNone/>
+            </a:pPr>
+            <a:r>
+              <a:rPr lang="en-US" b="1" kern="0" spc="200" dirty="0">
+                <a:solidFill>
+                  <a:srgbClr val="8FD6B8"/>
+                </a:solidFill>
+                <a:latin typeface="Calibri" pitchFamily="34" charset="0"/>
+                <a:ea typeface="Calibri" pitchFamily="34" charset="-122"/>
+                <a:cs typeface="Calibri" pitchFamily="34" charset="-120"/>
+              </a:rPr>
+              <a:t>Link: </a:t>
+            </a:r>
+            <a:r>
+              <a:rPr lang="en-US" b="1" kern="0" spc="200" dirty="0">
+                <a:solidFill>
+                  <a:srgbClr val="8FD6B8"/>
+                </a:solidFill>
+                <a:latin typeface="Calibri" pitchFamily="34" charset="0"/>
+                <a:ea typeface="Calibri" pitchFamily="34" charset="-122"/>
+                <a:cs typeface="Calibri" pitchFamily="34" charset="-120"/>
+                <a:hlinkClick r:id="rId4"/>
+              </a:rPr>
+              <a:t>GitHub</a:t>
+            </a:r>
+            <a:endParaRPr lang="en-US" dirty="0"/>
           </a:p>
         </p:txBody>
       </p:sp>
@@ -2780,6 +2648,7 @@
         <a:solidFill>
           <a:srgbClr val="F7F8F5"/>
         </a:solidFill>
+        <a:effectLst/>
       </p:bgPr>
     </p:bg>
     <p:spTree>
@@ -2817,11 +2686,11 @@
           <a:bodyPr wrap="square" lIns="0" tIns="0" rIns="0" bIns="0" rtlCol="0" anchor="ctr"/>
           <a:lstStyle/>
           <a:p>
-            <a:pPr indent="0" marL="0">
-              <a:buNone/>
-            </a:pPr>
-            <a:r>
-              <a:rPr lang="en-US" sz="1200" b="1" spc="200" kern="0" dirty="0">
+            <a:pPr marL="0" indent="0">
+              <a:buNone/>
+            </a:pPr>
+            <a:r>
+              <a:rPr lang="en-US" sz="1200" b="1" kern="0" spc="200" dirty="0">
                 <a:solidFill>
                   <a:srgbClr val="2F6F5E"/>
                 </a:solidFill>
@@ -2856,7 +2725,7 @@
           <a:bodyPr wrap="square" lIns="0" tIns="0" rIns="0" bIns="0" rtlCol="0" anchor="ctr"/>
           <a:lstStyle/>
           <a:p>
-            <a:pPr indent="0" marL="0">
+            <a:pPr marL="0" indent="0">
               <a:buNone/>
             </a:pPr>
             <a:r>
@@ -2895,7 +2764,7 @@
           <a:bodyPr wrap="square" lIns="0" tIns="0" rIns="0" bIns="0" rtlCol="0" anchor="ctr"/>
           <a:lstStyle/>
           <a:p>
-            <a:pPr indent="0" marL="0">
+            <a:pPr marL="0" indent="0">
               <a:buNone/>
             </a:pPr>
             <a:r>
@@ -2939,17 +2808,24 @@
             <a:prstDash val="solid"/>
           </a:ln>
         </p:spPr>
+        <p:txBody>
+          <a:bodyPr/>
+          <a:lstStyle/>
+          <a:p>
+            <a:endParaRPr lang="es-ES"/>
+          </a:p>
+        </p:txBody>
       </p:sp>
       <p:pic>
         <p:nvPicPr>
-          <p:cNvPr id="6" name="Image 0" descr="C:\Users\melpe\AppData\Local\Temp\claude\D--Ismael-DESARROLLO-lumio-notas-proyecto-claude\2a3cac32-8aea-4b5c-8de5-c2c7e1550d08\scratchpad\ppt_assets\docx_media\word\media\image11.png">    </p:cNvPr>
+          <p:cNvPr id="6" name="Image 0" descr="C:\Users\melpe\AppData\Local\Temp\claude\D--Ismael-DESARROLLO-lumio-notas-proyecto-claude\2a3cac32-8aea-4b5c-8de5-c2c7e1550d08\scratchpad\ppt_assets\docx_media\word\media\image11.png"/>
           <p:cNvPicPr>
             <a:picLocks noChangeAspect="1"/>
           </p:cNvPicPr>
           <p:nvPr/>
         </p:nvPicPr>
         <p:blipFill>
-          <a:blip r:embed="rId1"/>
+          <a:blip r:embed="rId3"/>
           <a:stretch>
             <a:fillRect/>
           </a:stretch>
@@ -2985,7 +2861,7 @@
           <a:bodyPr wrap="square" lIns="0" tIns="0" rIns="0" bIns="0" rtlCol="0" anchor="ctr"/>
           <a:lstStyle/>
           <a:p>
-            <a:pPr algn="r" indent="0" marL="0">
+            <a:pPr marL="0" indent="0" algn="r">
               <a:buNone/>
             </a:pPr>
             <a:r>
@@ -3000,6 +2876,63 @@
               <a:t>11</a:t>
             </a:r>
             <a:endParaRPr lang="en-US" sz="1000" dirty="0"/>
+          </a:p>
+        </p:txBody>
+      </p:sp>
+      <p:sp>
+        <p:nvSpPr>
+          <p:cNvPr id="8" name="Text 3">
+            <a:extLst>
+              <a:ext uri="{FF2B5EF4-FFF2-40B4-BE49-F238E27FC236}">
+                <a16:creationId xmlns:a16="http://schemas.microsoft.com/office/drawing/2014/main" id="{B2A6C0ED-9401-E97A-D100-E3FBEE4643B4}"/>
+              </a:ext>
+            </a:extLst>
+          </p:cNvPr>
+          <p:cNvSpPr/>
+          <p:nvPr/>
+        </p:nvSpPr>
+        <p:spPr>
+          <a:xfrm>
+            <a:off x="9807191" y="6036061"/>
+            <a:ext cx="1788607" cy="457200"/>
+          </a:xfrm>
+          <a:prstGeom prst="rect">
+            <a:avLst/>
+          </a:prstGeom>
+          <a:noFill/>
+          <a:ln/>
+        </p:spPr>
+        <p:txBody>
+          <a:bodyPr wrap="square" lIns="0" tIns="0" rIns="0" bIns="0" rtlCol="0" anchor="ctr"/>
+          <a:lstStyle/>
+          <a:p>
+            <a:pPr marL="0" indent="0">
+              <a:buNone/>
+            </a:pPr>
+            <a:r>
+              <a:rPr lang="en-US" b="1" kern="0" spc="200" dirty="0">
+                <a:solidFill>
+                  <a:srgbClr val="8FD6B8"/>
+                </a:solidFill>
+                <a:latin typeface="Calibri" pitchFamily="34" charset="0"/>
+                <a:ea typeface="Calibri" pitchFamily="34" charset="-122"/>
+                <a:cs typeface="Calibri" pitchFamily="34" charset="-120"/>
+              </a:rPr>
+              <a:t>Link: </a:t>
+            </a:r>
+            <a:r>
+              <a:rPr lang="en-US" b="1" kern="0" spc="200" dirty="0">
+                <a:solidFill>
+                  <a:srgbClr val="8FD6B8"/>
+                </a:solidFill>
+                <a:latin typeface="Calibri" pitchFamily="34" charset="0"/>
+                <a:ea typeface="Calibri" pitchFamily="34" charset="-122"/>
+                <a:cs typeface="Calibri" pitchFamily="34" charset="-120"/>
+                <a:hlinkClick r:id="rId4"/>
+              </a:rPr>
+              <a:t>GitHub</a:t>
+            </a:r>
+            <a:endParaRPr lang="en-US" dirty="0"/>
           </a:p>
         </p:txBody>
       </p:sp>
@@ -3019,6 +2952,7 @@
         <a:solidFill>
           <a:srgbClr val="F7F8F5"/>
         </a:solidFill>
+        <a:effectLst/>
       </p:bgPr>
     </p:bg>
     <p:spTree>
@@ -3056,11 +2990,11 @@
           <a:bodyPr wrap="square" lIns="0" tIns="0" rIns="0" bIns="0" rtlCol="0" anchor="ctr"/>
           <a:lstStyle/>
           <a:p>
-            <a:pPr indent="0" marL="0">
-              <a:buNone/>
-            </a:pPr>
-            <a:r>
-              <a:rPr lang="en-US" sz="1200" b="1" spc="200" kern="0" dirty="0">
+            <a:pPr marL="0" indent="0">
+              <a:buNone/>
+            </a:pPr>
+            <a:r>
+              <a:rPr lang="en-US" sz="1200" b="1" kern="0" spc="200" dirty="0">
                 <a:solidFill>
                   <a:srgbClr val="2F6F5E"/>
                 </a:solidFill>
@@ -3095,7 +3029,7 @@
           <a:bodyPr wrap="square" lIns="0" tIns="0" rIns="0" bIns="0" rtlCol="0" anchor="ctr"/>
           <a:lstStyle/>
           <a:p>
-            <a:pPr indent="0" marL="0">
+            <a:pPr marL="0" indent="0">
               <a:buNone/>
             </a:pPr>
             <a:r>
@@ -3134,7 +3068,7 @@
           <a:bodyPr wrap="square" lIns="0" tIns="0" rIns="0" bIns="0" rtlCol="0" anchor="ctr"/>
           <a:lstStyle/>
           <a:p>
-            <a:pPr indent="0" marL="0">
+            <a:pPr marL="0" indent="0">
               <a:buNone/>
             </a:pPr>
             <a:r>
@@ -3178,17 +3112,24 @@
             <a:prstDash val="solid"/>
           </a:ln>
         </p:spPr>
+        <p:txBody>
+          <a:bodyPr/>
+          <a:lstStyle/>
+          <a:p>
+            <a:endParaRPr lang="es-ES"/>
+          </a:p>
+        </p:txBody>
       </p:sp>
       <p:pic>
         <p:nvPicPr>
-          <p:cNvPr id="6" name="Image 0" descr="D:\Ismael\DESARROLLO\aplicaciones_distribuidas\proyecto-soap-productos\evidencias\00_WSDL_importado.jpg">    </p:cNvPr>
+          <p:cNvPr id="6" name="Image 0" descr="D:\Ismael\DESARROLLO\aplicaciones_distribuidas\proyecto-soap-productos\evidencias\00_WSDL_importado.jpg"/>
           <p:cNvPicPr>
             <a:picLocks noChangeAspect="1"/>
           </p:cNvPicPr>
           <p:nvPr/>
         </p:nvPicPr>
         <p:blipFill>
-          <a:blip r:embed="rId1"/>
+          <a:blip r:embed="rId3"/>
           <a:stretch>
             <a:fillRect/>
           </a:stretch>
@@ -3229,17 +3170,24 @@
             <a:prstDash val="solid"/>
           </a:ln>
         </p:spPr>
+        <p:txBody>
+          <a:bodyPr/>
+          <a:lstStyle/>
+          <a:p>
+            <a:endParaRPr lang="es-ES"/>
+          </a:p>
+        </p:txBody>
       </p:sp>
       <p:pic>
         <p:nvPicPr>
-          <p:cNvPr id="8" name="Image 1" descr="D:\Ismael\DESARROLLO\aplicaciones_distribuidas\proyecto-soap-productos\evidencias\01_RegistrarProducto_correcto.jpg">    </p:cNvPr>
+          <p:cNvPr id="8" name="Image 1" descr="D:\Ismael\DESARROLLO\aplicaciones_distribuidas\proyecto-soap-productos\evidencias\01_RegistrarProducto_correcto.jpg"/>
           <p:cNvPicPr>
             <a:picLocks noChangeAspect="1"/>
           </p:cNvPicPr>
           <p:nvPr/>
         </p:nvPicPr>
         <p:blipFill>
-          <a:blip r:embed="rId2"/>
+          <a:blip r:embed="rId4"/>
           <a:stretch>
             <a:fillRect/>
           </a:stretch>
@@ -3275,7 +3223,7 @@
           <a:bodyPr wrap="square" lIns="0" tIns="0" rIns="0" bIns="0" rtlCol="0" anchor="ctr"/>
           <a:lstStyle/>
           <a:p>
-            <a:pPr indent="0" marL="0">
+            <a:pPr marL="0" indent="0">
               <a:buNone/>
             </a:pPr>
             <a:r>
@@ -3314,7 +3262,7 @@
           <a:bodyPr wrap="square" lIns="0" tIns="0" rIns="0" bIns="0" rtlCol="0" anchor="ctr"/>
           <a:lstStyle/>
           <a:p>
-            <a:pPr algn="r" indent="0" marL="0">
+            <a:pPr marL="0" indent="0" algn="r">
               <a:buNone/>
             </a:pPr>
             <a:r>
@@ -3329,6 +3277,63 @@
               <a:t>12</a:t>
             </a:r>
             <a:endParaRPr lang="en-US" sz="1000" dirty="0"/>
+          </a:p>
+        </p:txBody>
+      </p:sp>
+      <p:sp>
+        <p:nvSpPr>
+          <p:cNvPr id="11" name="Text 3">
+            <a:extLst>
+              <a:ext uri="{FF2B5EF4-FFF2-40B4-BE49-F238E27FC236}">
+                <a16:creationId xmlns:a16="http://schemas.microsoft.com/office/drawing/2014/main" id="{E9D3997E-F67A-496D-C54B-7C948F54FD99}"/>
+              </a:ext>
+            </a:extLst>
+          </p:cNvPr>
+          <p:cNvSpPr/>
+          <p:nvPr/>
+        </p:nvSpPr>
+        <p:spPr>
+          <a:xfrm>
+            <a:off x="9807191" y="6036061"/>
+            <a:ext cx="1788607" cy="457200"/>
+          </a:xfrm>
+          <a:prstGeom prst="rect">
+            <a:avLst/>
+          </a:prstGeom>
+          <a:noFill/>
+          <a:ln/>
+        </p:spPr>
+        <p:txBody>
+          <a:bodyPr wrap="square" lIns="0" tIns="0" rIns="0" bIns="0" rtlCol="0" anchor="ctr"/>
+          <a:lstStyle/>
+          <a:p>
+            <a:pPr marL="0" indent="0">
+              <a:buNone/>
+            </a:pPr>
+            <a:r>
+              <a:rPr lang="en-US" b="1" kern="0" spc="200" dirty="0">
+                <a:solidFill>
+                  <a:srgbClr val="8FD6B8"/>
+                </a:solidFill>
+                <a:latin typeface="Calibri" pitchFamily="34" charset="0"/>
+                <a:ea typeface="Calibri" pitchFamily="34" charset="-122"/>
+                <a:cs typeface="Calibri" pitchFamily="34" charset="-120"/>
+              </a:rPr>
+              <a:t>Link: </a:t>
+            </a:r>
+            <a:r>
+              <a:rPr lang="en-US" b="1" kern="0" spc="200" dirty="0">
+                <a:solidFill>
+                  <a:srgbClr val="8FD6B8"/>
+                </a:solidFill>
+                <a:latin typeface="Calibri" pitchFamily="34" charset="0"/>
+                <a:ea typeface="Calibri" pitchFamily="34" charset="-122"/>
+                <a:cs typeface="Calibri" pitchFamily="34" charset="-120"/>
+                <a:hlinkClick r:id="rId5"/>
+              </a:rPr>
+              <a:t>GitHub</a:t>
+            </a:r>
+            <a:endParaRPr lang="en-US" dirty="0"/>
           </a:p>
         </p:txBody>
       </p:sp>
@@ -3348,6 +3353,7 @@
         <a:solidFill>
           <a:srgbClr val="16211D"/>
         </a:solidFill>
+        <a:effectLst/>
       </p:bgPr>
     </p:bg>
     <p:spTree>
@@ -3385,11 +3391,11 @@
           <a:bodyPr wrap="square" lIns="0" tIns="0" rIns="0" bIns="0" rtlCol="0" anchor="ctr"/>
           <a:lstStyle/>
           <a:p>
-            <a:pPr indent="0" marL="0">
-              <a:buNone/>
-            </a:pPr>
-            <a:r>
-              <a:rPr lang="en-US" sz="1200" b="1" spc="200" kern="0" dirty="0">
+            <a:pPr marL="0" indent="0">
+              <a:buNone/>
+            </a:pPr>
+            <a:r>
+              <a:rPr lang="en-US" sz="1200" b="1" kern="0" spc="200" dirty="0">
                 <a:solidFill>
                   <a:srgbClr val="8FD6B8"/>
                 </a:solidFill>
@@ -3424,7 +3430,7 @@
           <a:bodyPr wrap="square" lIns="0" tIns="0" rIns="0" bIns="0" rtlCol="0" anchor="ctr"/>
           <a:lstStyle/>
           <a:p>
-            <a:pPr indent="0" marL="0">
+            <a:pPr marL="0" indent="0">
               <a:buNone/>
             </a:pPr>
             <a:r>
@@ -3463,7 +3469,7 @@
           <a:bodyPr wrap="square" lIns="0" tIns="0" rIns="0" bIns="0" rtlCol="0" anchor="ctr"/>
           <a:lstStyle/>
           <a:p>
-            <a:pPr indent="0" marL="0">
+            <a:pPr marL="0" indent="0">
               <a:buNone/>
             </a:pPr>
             <a:r>
@@ -3483,14 +3489,14 @@
       </p:sp>
       <p:pic>
         <p:nvPicPr>
-          <p:cNvPr id="5" name="Image 0" descr="C:\Users\melpe\AppData\Local\Temp\claude\D--Ismael-DESARROLLO-lumio-notas-proyecto-claude\2a3cac32-8aea-4b5c-8de5-c2c7e1550d08\scratchpad\ppt_assets\docx_media\word\media\image12.png">    </p:cNvPr>
+          <p:cNvPr id="5" name="Image 0" descr="C:\Users\melpe\AppData\Local\Temp\claude\D--Ismael-DESARROLLO-lumio-notas-proyecto-claude\2a3cac32-8aea-4b5c-8de5-c2c7e1550d08\scratchpad\ppt_assets\docx_media\word\media\image12.png"/>
           <p:cNvPicPr>
             <a:picLocks noChangeAspect="1"/>
           </p:cNvPicPr>
           <p:nvPr/>
         </p:nvPicPr>
         <p:blipFill>
-          <a:blip r:embed="rId1"/>
+          <a:blip r:embed="rId3"/>
           <a:stretch>
             <a:fillRect/>
           </a:stretch>
@@ -3526,7 +3532,7 @@
           <a:bodyPr wrap="square" lIns="0" tIns="0" rIns="0" bIns="0" rtlCol="0" anchor="ctr"/>
           <a:lstStyle/>
           <a:p>
-            <a:pPr indent="0" marL="0">
+            <a:pPr marL="0" indent="0">
               <a:buNone/>
             </a:pPr>
             <a:r>
@@ -3546,14 +3552,14 @@
       </p:sp>
       <p:pic>
         <p:nvPicPr>
-          <p:cNvPr id="7" name="Image 1" descr="C:\Users\melpe\AppData\Local\Temp\claude\D--Ismael-DESARROLLO-lumio-notas-proyecto-claude\2a3cac32-8aea-4b5c-8de5-c2c7e1550d08\scratchpad\ppt_assets\docx_media\word\media\image13.png">    </p:cNvPr>
+          <p:cNvPr id="7" name="Image 1" descr="C:\Users\melpe\AppData\Local\Temp\claude\D--Ismael-DESARROLLO-lumio-notas-proyecto-claude\2a3cac32-8aea-4b5c-8de5-c2c7e1550d08\scratchpad\ppt_assets\docx_media\word\media\image13.png"/>
           <p:cNvPicPr>
             <a:picLocks noChangeAspect="1"/>
           </p:cNvPicPr>
           <p:nvPr/>
         </p:nvPicPr>
         <p:blipFill>
-          <a:blip r:embed="rId2"/>
+          <a:blip r:embed="rId4"/>
           <a:stretch>
             <a:fillRect/>
           </a:stretch>
@@ -3589,7 +3595,7 @@
           <a:bodyPr wrap="square" lIns="0" tIns="0" rIns="0" bIns="0" rtlCol="0" anchor="ctr"/>
           <a:lstStyle/>
           <a:p>
-            <a:pPr indent="0" marL="0">
+            <a:pPr marL="0" indent="0">
               <a:buNone/>
             </a:pPr>
             <a:r>
@@ -3628,7 +3634,7 @@
           <a:bodyPr wrap="square" lIns="0" tIns="0" rIns="0" bIns="0" rtlCol="0" anchor="ctr"/>
           <a:lstStyle/>
           <a:p>
-            <a:pPr algn="r" indent="0" marL="0">
+            <a:pPr marL="0" indent="0" algn="r">
               <a:buNone/>
             </a:pPr>
             <a:r>
@@ -3643,6 +3649,63 @@
               <a:t>13</a:t>
             </a:r>
             <a:endParaRPr lang="en-US" sz="1000" dirty="0"/>
+          </a:p>
+        </p:txBody>
+      </p:sp>
+      <p:sp>
+        <p:nvSpPr>
+          <p:cNvPr id="10" name="Text 3">
+            <a:extLst>
+              <a:ext uri="{FF2B5EF4-FFF2-40B4-BE49-F238E27FC236}">
+                <a16:creationId xmlns:a16="http://schemas.microsoft.com/office/drawing/2014/main" id="{BE2CF6F3-5DD2-02F4-171D-80A4B2538B26}"/>
+              </a:ext>
+            </a:extLst>
+          </p:cNvPr>
+          <p:cNvSpPr/>
+          <p:nvPr/>
+        </p:nvSpPr>
+        <p:spPr>
+          <a:xfrm>
+            <a:off x="9807191" y="6036061"/>
+            <a:ext cx="1788607" cy="457200"/>
+          </a:xfrm>
+          <a:prstGeom prst="rect">
+            <a:avLst/>
+          </a:prstGeom>
+          <a:noFill/>
+          <a:ln/>
+        </p:spPr>
+        <p:txBody>
+          <a:bodyPr wrap="square" lIns="0" tIns="0" rIns="0" bIns="0" rtlCol="0" anchor="ctr"/>
+          <a:lstStyle/>
+          <a:p>
+            <a:pPr marL="0" indent="0">
+              <a:buNone/>
+            </a:pPr>
+            <a:r>
+              <a:rPr lang="en-US" b="1" kern="0" spc="200" dirty="0">
+                <a:solidFill>
+                  <a:srgbClr val="8FD6B8"/>
+                </a:solidFill>
+                <a:latin typeface="Calibri" pitchFamily="34" charset="0"/>
+                <a:ea typeface="Calibri" pitchFamily="34" charset="-122"/>
+                <a:cs typeface="Calibri" pitchFamily="34" charset="-120"/>
+              </a:rPr>
+              <a:t>Link: </a:t>
+            </a:r>
+            <a:r>
+              <a:rPr lang="en-US" b="1" kern="0" spc="200" dirty="0">
+                <a:solidFill>
+                  <a:srgbClr val="8FD6B8"/>
+                </a:solidFill>
+                <a:latin typeface="Calibri" pitchFamily="34" charset="0"/>
+                <a:ea typeface="Calibri" pitchFamily="34" charset="-122"/>
+                <a:cs typeface="Calibri" pitchFamily="34" charset="-120"/>
+                <a:hlinkClick r:id="rId5"/>
+              </a:rPr>
+              <a:t>GitHub</a:t>
+            </a:r>
+            <a:endParaRPr lang="en-US" dirty="0"/>
           </a:p>
         </p:txBody>
       </p:sp>
@@ -3662,6 +3725,7 @@
         <a:solidFill>
           <a:srgbClr val="F7F8F5"/>
         </a:solidFill>
+        <a:effectLst/>
       </p:bgPr>
     </p:bg>
     <p:spTree>
@@ -3699,11 +3763,11 @@
           <a:bodyPr wrap="square" lIns="0" tIns="0" rIns="0" bIns="0" rtlCol="0" anchor="ctr"/>
           <a:lstStyle/>
           <a:p>
-            <a:pPr indent="0" marL="0">
-              <a:buNone/>
-            </a:pPr>
-            <a:r>
-              <a:rPr lang="en-US" sz="1200" b="1" spc="200" kern="0" dirty="0">
+            <a:pPr marL="0" indent="0">
+              <a:buNone/>
+            </a:pPr>
+            <a:r>
+              <a:rPr lang="en-US" sz="1200" b="1" kern="0" spc="200" dirty="0">
                 <a:solidFill>
                   <a:srgbClr val="2F6F5E"/>
                 </a:solidFill>
@@ -3738,7 +3802,7 @@
           <a:bodyPr wrap="square" lIns="0" tIns="0" rIns="0" bIns="0" rtlCol="0" anchor="ctr"/>
           <a:lstStyle/>
           <a:p>
-            <a:pPr indent="0" marL="0">
+            <a:pPr marL="0" indent="0">
               <a:buNone/>
             </a:pPr>
             <a:r>
@@ -3782,6 +3846,13 @@
             <a:prstDash val="solid"/>
           </a:ln>
         </p:spPr>
+        <p:txBody>
+          <a:bodyPr/>
+          <a:lstStyle/>
+          <a:p>
+            <a:endParaRPr lang="es-ES"/>
+          </a:p>
+        </p:txBody>
       </p:sp>
       <p:sp>
         <p:nvSpPr>
@@ -3802,6 +3873,13 @@
           </a:solidFill>
           <a:ln/>
         </p:spPr>
+        <p:txBody>
+          <a:bodyPr/>
+          <a:lstStyle/>
+          <a:p>
+            <a:endParaRPr lang="es-ES"/>
+          </a:p>
+        </p:txBody>
       </p:sp>
       <p:sp>
         <p:nvSpPr>
@@ -3824,7 +3902,7 @@
           <a:bodyPr wrap="square" lIns="0" tIns="0" rIns="0" bIns="0" rtlCol="0" anchor="ctr"/>
           <a:lstStyle/>
           <a:p>
-            <a:pPr algn="ctr" indent="0" marL="0">
+            <a:pPr marL="0" indent="0" algn="ctr">
               <a:buNone/>
             </a:pPr>
             <a:r>
@@ -3863,7 +3941,7 @@
           <a:bodyPr wrap="square" lIns="0" tIns="0" rIns="0" bIns="0" rtlCol="0" anchor="ctr"/>
           <a:lstStyle/>
           <a:p>
-            <a:pPr indent="0" marL="0">
+            <a:pPr marL="0" indent="0">
               <a:lnSpc>
                 <a:spcPts val="1800"/>
               </a:lnSpc>
@@ -3905,7 +3983,7 @@
           <a:bodyPr wrap="square" lIns="0" tIns="0" rIns="0" bIns="0" rtlCol="0" anchor="ctr"/>
           <a:lstStyle/>
           <a:p>
-            <a:pPr indent="0" marL="0">
+            <a:pPr marL="0" indent="0">
               <a:lnSpc>
                 <a:spcPts val="1500"/>
               </a:lnSpc>
@@ -3952,6 +4030,13 @@
             <a:prstDash val="solid"/>
           </a:ln>
         </p:spPr>
+        <p:txBody>
+          <a:bodyPr/>
+          <a:lstStyle/>
+          <a:p>
+            <a:endParaRPr lang="es-ES"/>
+          </a:p>
+        </p:txBody>
       </p:sp>
       <p:sp>
         <p:nvSpPr>
@@ -3972,6 +4057,13 @@
           </a:solidFill>
           <a:ln/>
         </p:spPr>
+        <p:txBody>
+          <a:bodyPr/>
+          <a:lstStyle/>
+          <a:p>
+            <a:endParaRPr lang="es-ES"/>
+          </a:p>
+        </p:txBody>
       </p:sp>
       <p:sp>
         <p:nvSpPr>
@@ -3994,7 +4086,7 @@
           <a:bodyPr wrap="square" lIns="0" tIns="0" rIns="0" bIns="0" rtlCol="0" anchor="ctr"/>
           <a:lstStyle/>
           <a:p>
-            <a:pPr algn="ctr" indent="0" marL="0">
+            <a:pPr marL="0" indent="0" algn="ctr">
               <a:buNone/>
             </a:pPr>
             <a:r>
@@ -4033,7 +4125,7 @@
           <a:bodyPr wrap="square" lIns="0" tIns="0" rIns="0" bIns="0" rtlCol="0" anchor="ctr"/>
           <a:lstStyle/>
           <a:p>
-            <a:pPr indent="0" marL="0">
+            <a:pPr marL="0" indent="0">
               <a:lnSpc>
                 <a:spcPts val="1800"/>
               </a:lnSpc>
@@ -4075,7 +4167,7 @@
           <a:bodyPr wrap="square" lIns="0" tIns="0" rIns="0" bIns="0" rtlCol="0" anchor="ctr"/>
           <a:lstStyle/>
           <a:p>
-            <a:pPr indent="0" marL="0">
+            <a:pPr marL="0" indent="0">
               <a:lnSpc>
                 <a:spcPts val="1500"/>
               </a:lnSpc>
@@ -4122,6 +4214,13 @@
             <a:prstDash val="solid"/>
           </a:ln>
         </p:spPr>
+        <p:txBody>
+          <a:bodyPr/>
+          <a:lstStyle/>
+          <a:p>
+            <a:endParaRPr lang="es-ES"/>
+          </a:p>
+        </p:txBody>
       </p:sp>
       <p:sp>
         <p:nvSpPr>
@@ -4142,6 +4241,13 @@
           </a:solidFill>
           <a:ln/>
         </p:spPr>
+        <p:txBody>
+          <a:bodyPr/>
+          <a:lstStyle/>
+          <a:p>
+            <a:endParaRPr lang="es-ES"/>
+          </a:p>
+        </p:txBody>
       </p:sp>
       <p:sp>
         <p:nvSpPr>
@@ -4164,7 +4270,7 @@
           <a:bodyPr wrap="square" lIns="0" tIns="0" rIns="0" bIns="0" rtlCol="0" anchor="ctr"/>
           <a:lstStyle/>
           <a:p>
-            <a:pPr algn="ctr" indent="0" marL="0">
+            <a:pPr marL="0" indent="0" algn="ctr">
               <a:buNone/>
             </a:pPr>
             <a:r>
@@ -4203,7 +4309,7 @@
           <a:bodyPr wrap="square" lIns="0" tIns="0" rIns="0" bIns="0" rtlCol="0" anchor="ctr"/>
           <a:lstStyle/>
           <a:p>
-            <a:pPr indent="0" marL="0">
+            <a:pPr marL="0" indent="0">
               <a:lnSpc>
                 <a:spcPts val="1800"/>
               </a:lnSpc>
@@ -4245,7 +4351,7 @@
           <a:bodyPr wrap="square" lIns="0" tIns="0" rIns="0" bIns="0" rtlCol="0" anchor="ctr"/>
           <a:lstStyle/>
           <a:p>
-            <a:pPr indent="0" marL="0">
+            <a:pPr marL="0" indent="0">
               <a:lnSpc>
                 <a:spcPts val="1500"/>
               </a:lnSpc>
@@ -4287,7 +4393,7 @@
           <a:bodyPr wrap="square" lIns="0" tIns="0" rIns="0" bIns="0" rtlCol="0" anchor="ctr"/>
           <a:lstStyle/>
           <a:p>
-            <a:pPr algn="r" indent="0" marL="0">
+            <a:pPr marL="0" indent="0" algn="r">
               <a:buNone/>
             </a:pPr>
             <a:r>
@@ -4302,6 +4408,63 @@
               <a:t>14</a:t>
             </a:r>
             <a:endParaRPr lang="en-US" sz="1000" dirty="0"/>
+          </a:p>
+        </p:txBody>
+      </p:sp>
+      <p:sp>
+        <p:nvSpPr>
+          <p:cNvPr id="20" name="Text 3">
+            <a:extLst>
+              <a:ext uri="{FF2B5EF4-FFF2-40B4-BE49-F238E27FC236}">
+                <a16:creationId xmlns:a16="http://schemas.microsoft.com/office/drawing/2014/main" id="{6CCF39F2-EF30-1D9B-7978-084BA29EF3C3}"/>
+              </a:ext>
+            </a:extLst>
+          </p:cNvPr>
+          <p:cNvSpPr/>
+          <p:nvPr/>
+        </p:nvSpPr>
+        <p:spPr>
+          <a:xfrm>
+            <a:off x="9807191" y="6036061"/>
+            <a:ext cx="1788607" cy="457200"/>
+          </a:xfrm>
+          <a:prstGeom prst="rect">
+            <a:avLst/>
+          </a:prstGeom>
+          <a:noFill/>
+          <a:ln/>
+        </p:spPr>
+        <p:txBody>
+          <a:bodyPr wrap="square" lIns="0" tIns="0" rIns="0" bIns="0" rtlCol="0" anchor="ctr"/>
+          <a:lstStyle/>
+          <a:p>
+            <a:pPr marL="0" indent="0">
+              <a:buNone/>
+            </a:pPr>
+            <a:r>
+              <a:rPr lang="en-US" b="1" kern="0" spc="200" dirty="0">
+                <a:solidFill>
+                  <a:srgbClr val="8FD6B8"/>
+                </a:solidFill>
+                <a:latin typeface="Calibri" pitchFamily="34" charset="0"/>
+                <a:ea typeface="Calibri" pitchFamily="34" charset="-122"/>
+                <a:cs typeface="Calibri" pitchFamily="34" charset="-120"/>
+              </a:rPr>
+              <a:t>Link: </a:t>
+            </a:r>
+            <a:r>
+              <a:rPr lang="en-US" b="1" kern="0" spc="200" dirty="0">
+                <a:solidFill>
+                  <a:srgbClr val="8FD6B8"/>
+                </a:solidFill>
+                <a:latin typeface="Calibri" pitchFamily="34" charset="0"/>
+                <a:ea typeface="Calibri" pitchFamily="34" charset="-122"/>
+                <a:cs typeface="Calibri" pitchFamily="34" charset="-120"/>
+                <a:hlinkClick r:id="rId3"/>
+              </a:rPr>
+              <a:t>GitHub</a:t>
+            </a:r>
+            <a:endParaRPr lang="en-US" dirty="0"/>
           </a:p>
         </p:txBody>
       </p:sp>
@@ -4321,6 +4484,7 @@
         <a:solidFill>
           <a:srgbClr val="F7F8F5"/>
         </a:solidFill>
+        <a:effectLst/>
       </p:bgPr>
     </p:bg>
     <p:spTree>
@@ -4358,11 +4522,11 @@
           <a:bodyPr wrap="square" lIns="0" tIns="0" rIns="0" bIns="0" rtlCol="0" anchor="ctr"/>
           <a:lstStyle/>
           <a:p>
-            <a:pPr indent="0" marL="0">
-              <a:buNone/>
-            </a:pPr>
-            <a:r>
-              <a:rPr lang="en-US" sz="1200" b="1" spc="200" kern="0" dirty="0">
+            <a:pPr marL="0" indent="0">
+              <a:buNone/>
+            </a:pPr>
+            <a:r>
+              <a:rPr lang="en-US" sz="1200" b="1" kern="0" spc="200" dirty="0">
                 <a:solidFill>
                   <a:srgbClr val="2F6F5E"/>
                 </a:solidFill>
@@ -4397,7 +4561,7 @@
           <a:bodyPr wrap="square" lIns="0" tIns="0" rIns="0" bIns="0" rtlCol="0" anchor="ctr"/>
           <a:lstStyle/>
           <a:p>
-            <a:pPr indent="0" marL="0">
+            <a:pPr marL="0" indent="0">
               <a:buNone/>
             </a:pPr>
             <a:r>
@@ -4434,6 +4598,13 @@
           </a:solidFill>
           <a:ln/>
         </p:spPr>
+        <p:txBody>
+          <a:bodyPr/>
+          <a:lstStyle/>
+          <a:p>
+            <a:endParaRPr lang="es-ES"/>
+          </a:p>
+        </p:txBody>
       </p:sp>
       <p:sp>
         <p:nvSpPr>
@@ -4456,7 +4627,7 @@
           <a:bodyPr wrap="square" lIns="0" tIns="0" rIns="0" bIns="0" rtlCol="0" anchor="ctr"/>
           <a:lstStyle/>
           <a:p>
-            <a:pPr algn="ctr" indent="0" marL="0">
+            <a:pPr marL="0" indent="0" algn="ctr">
               <a:buNone/>
             </a:pPr>
             <a:r>
@@ -4495,7 +4666,7 @@
           <a:bodyPr wrap="square" lIns="0" tIns="0" rIns="0" bIns="0" rtlCol="0" anchor="ctr"/>
           <a:lstStyle/>
           <a:p>
-            <a:pPr indent="0" marL="0">
+            <a:pPr marL="0" indent="0">
               <a:lnSpc>
                 <a:spcPts val="1900"/>
               </a:lnSpc>
@@ -4535,6 +4706,13 @@
           </a:solidFill>
           <a:ln/>
         </p:spPr>
+        <p:txBody>
+          <a:bodyPr/>
+          <a:lstStyle/>
+          <a:p>
+            <a:endParaRPr lang="es-ES"/>
+          </a:p>
+        </p:txBody>
       </p:sp>
       <p:sp>
         <p:nvSpPr>
@@ -4557,7 +4735,7 @@
           <a:bodyPr wrap="square" lIns="0" tIns="0" rIns="0" bIns="0" rtlCol="0" anchor="ctr"/>
           <a:lstStyle/>
           <a:p>
-            <a:pPr algn="ctr" indent="0" marL="0">
+            <a:pPr marL="0" indent="0" algn="ctr">
               <a:buNone/>
             </a:pPr>
             <a:r>
@@ -4596,7 +4774,7 @@
           <a:bodyPr wrap="square" lIns="0" tIns="0" rIns="0" bIns="0" rtlCol="0" anchor="ctr"/>
           <a:lstStyle/>
           <a:p>
-            <a:pPr indent="0" marL="0">
+            <a:pPr marL="0" indent="0">
               <a:lnSpc>
                 <a:spcPts val="1900"/>
               </a:lnSpc>
@@ -4636,6 +4814,13 @@
           </a:solidFill>
           <a:ln/>
         </p:spPr>
+        <p:txBody>
+          <a:bodyPr/>
+          <a:lstStyle/>
+          <a:p>
+            <a:endParaRPr lang="es-ES"/>
+          </a:p>
+        </p:txBody>
       </p:sp>
       <p:sp>
         <p:nvSpPr>
@@ -4658,7 +4843,7 @@
           <a:bodyPr wrap="square" lIns="0" tIns="0" rIns="0" bIns="0" rtlCol="0" anchor="ctr"/>
           <a:lstStyle/>
           <a:p>
-            <a:pPr algn="ctr" indent="0" marL="0">
+            <a:pPr marL="0" indent="0" algn="ctr">
               <a:buNone/>
             </a:pPr>
             <a:r>
@@ -4697,7 +4882,7 @@
           <a:bodyPr wrap="square" lIns="0" tIns="0" rIns="0" bIns="0" rtlCol="0" anchor="ctr"/>
           <a:lstStyle/>
           <a:p>
-            <a:pPr indent="0" marL="0">
+            <a:pPr marL="0" indent="0">
               <a:lnSpc>
                 <a:spcPts val="1900"/>
               </a:lnSpc>
@@ -4737,6 +4922,13 @@
           </a:solidFill>
           <a:ln/>
         </p:spPr>
+        <p:txBody>
+          <a:bodyPr/>
+          <a:lstStyle/>
+          <a:p>
+            <a:endParaRPr lang="es-ES"/>
+          </a:p>
+        </p:txBody>
       </p:sp>
       <p:sp>
         <p:nvSpPr>
@@ -4759,7 +4951,7 @@
           <a:bodyPr wrap="square" lIns="0" tIns="0" rIns="0" bIns="0" rtlCol="0" anchor="ctr"/>
           <a:lstStyle/>
           <a:p>
-            <a:pPr algn="ctr" indent="0" marL="0">
+            <a:pPr marL="0" indent="0" algn="ctr">
               <a:buNone/>
             </a:pPr>
             <a:r>
@@ -4798,7 +4990,7 @@
           <a:bodyPr wrap="square" lIns="0" tIns="0" rIns="0" bIns="0" rtlCol="0" anchor="ctr"/>
           <a:lstStyle/>
           <a:p>
-            <a:pPr indent="0" marL="0">
+            <a:pPr marL="0" indent="0">
               <a:lnSpc>
                 <a:spcPts val="1900"/>
               </a:lnSpc>
@@ -4840,7 +5032,7 @@
           <a:bodyPr wrap="square" lIns="0" tIns="0" rIns="0" bIns="0" rtlCol="0" anchor="ctr"/>
           <a:lstStyle/>
           <a:p>
-            <a:pPr algn="r" indent="0" marL="0">
+            <a:pPr marL="0" indent="0" algn="r">
               <a:buNone/>
             </a:pPr>
             <a:r>
@@ -4855,6 +5047,63 @@
               <a:t>15</a:t>
             </a:r>
             <a:endParaRPr lang="en-US" sz="1000" dirty="0"/>
+          </a:p>
+        </p:txBody>
+      </p:sp>
+      <p:sp>
+        <p:nvSpPr>
+          <p:cNvPr id="17" name="Text 3">
+            <a:extLst>
+              <a:ext uri="{FF2B5EF4-FFF2-40B4-BE49-F238E27FC236}">
+                <a16:creationId xmlns:a16="http://schemas.microsoft.com/office/drawing/2014/main" id="{33E4EF41-634B-4B8F-9339-31A3E2A52B53}"/>
+              </a:ext>
+            </a:extLst>
+          </p:cNvPr>
+          <p:cNvSpPr/>
+          <p:nvPr/>
+        </p:nvSpPr>
+        <p:spPr>
+          <a:xfrm>
+            <a:off x="9807191" y="6036061"/>
+            <a:ext cx="1788607" cy="457200"/>
+          </a:xfrm>
+          <a:prstGeom prst="rect">
+            <a:avLst/>
+          </a:prstGeom>
+          <a:noFill/>
+          <a:ln/>
+        </p:spPr>
+        <p:txBody>
+          <a:bodyPr wrap="square" lIns="0" tIns="0" rIns="0" bIns="0" rtlCol="0" anchor="ctr"/>
+          <a:lstStyle/>
+          <a:p>
+            <a:pPr marL="0" indent="0">
+              <a:buNone/>
+            </a:pPr>
+            <a:r>
+              <a:rPr lang="en-US" b="1" kern="0" spc="200" dirty="0">
+                <a:solidFill>
+                  <a:srgbClr val="8FD6B8"/>
+                </a:solidFill>
+                <a:latin typeface="Calibri" pitchFamily="34" charset="0"/>
+                <a:ea typeface="Calibri" pitchFamily="34" charset="-122"/>
+                <a:cs typeface="Calibri" pitchFamily="34" charset="-120"/>
+              </a:rPr>
+              <a:t>Link: </a:t>
+            </a:r>
+            <a:r>
+              <a:rPr lang="en-US" b="1" kern="0" spc="200" dirty="0">
+                <a:solidFill>
+                  <a:srgbClr val="8FD6B8"/>
+                </a:solidFill>
+                <a:latin typeface="Calibri" pitchFamily="34" charset="0"/>
+                <a:ea typeface="Calibri" pitchFamily="34" charset="-122"/>
+                <a:cs typeface="Calibri" pitchFamily="34" charset="-120"/>
+                <a:hlinkClick r:id="rId3"/>
+              </a:rPr>
+              <a:t>GitHub</a:t>
+            </a:r>
+            <a:endParaRPr lang="en-US" dirty="0"/>
           </a:p>
         </p:txBody>
       </p:sp>
@@ -4874,6 +5123,7 @@
         <a:solidFill>
           <a:srgbClr val="16211D"/>
         </a:solidFill>
+        <a:effectLst/>
       </p:bgPr>
     </p:bg>
     <p:spTree>
@@ -4909,6 +5159,13 @@
           </a:solidFill>
           <a:ln/>
         </p:spPr>
+        <p:txBody>
+          <a:bodyPr/>
+          <a:lstStyle/>
+          <a:p>
+            <a:endParaRPr lang="es-ES"/>
+          </a:p>
+        </p:txBody>
       </p:sp>
       <p:sp>
         <p:nvSpPr>
@@ -4931,7 +5188,7 @@
           <a:bodyPr wrap="square" lIns="0" tIns="0" rIns="0" bIns="0" rtlCol="0" anchor="ctr"/>
           <a:lstStyle/>
           <a:p>
-            <a:pPr algn="ctr" indent="0" marL="0">
+            <a:pPr marL="0" indent="0" algn="ctr">
               <a:buNone/>
             </a:pPr>
             <a:r>
@@ -4970,7 +5227,7 @@
           <a:bodyPr wrap="square" lIns="0" tIns="0" rIns="0" bIns="0" rtlCol="0" anchor="ctr"/>
           <a:lstStyle/>
           <a:p>
-            <a:pPr algn="ctr" indent="0" marL="0">
+            <a:pPr marL="0" indent="0" algn="ctr">
               <a:buNone/>
             </a:pPr>
             <a:r>
@@ -5009,7 +5266,7 @@
           <a:bodyPr wrap="square" lIns="0" tIns="0" rIns="0" bIns="0" rtlCol="0" anchor="ctr"/>
           <a:lstStyle/>
           <a:p>
-            <a:pPr algn="ctr" indent="0" marL="0">
+            <a:pPr marL="0" indent="0" algn="ctr">
               <a:buNone/>
             </a:pPr>
             <a:r>
@@ -5048,7 +5305,7 @@
           <a:bodyPr wrap="square" lIns="0" tIns="0" rIns="0" bIns="0" rtlCol="0" anchor="ctr"/>
           <a:lstStyle/>
           <a:p>
-            <a:pPr algn="ctr" indent="0" marL="0">
+            <a:pPr marL="0" indent="0" algn="ctr">
               <a:buNone/>
             </a:pPr>
             <a:r>
@@ -5087,7 +5344,7 @@
           <a:bodyPr wrap="square" lIns="0" tIns="0" rIns="0" bIns="0" rtlCol="0" anchor="ctr"/>
           <a:lstStyle/>
           <a:p>
-            <a:pPr algn="ctr" indent="0" marL="0">
+            <a:pPr marL="0" indent="0" algn="ctr">
               <a:buNone/>
             </a:pPr>
             <a:r>
@@ -5121,6 +5378,7 @@
         <a:solidFill>
           <a:srgbClr val="F7F8F5"/>
         </a:solidFill>
+        <a:effectLst/>
       </p:bgPr>
     </p:bg>
     <p:spTree>
@@ -5158,11 +5416,11 @@
           <a:bodyPr wrap="square" lIns="0" tIns="0" rIns="0" bIns="0" rtlCol="0" anchor="ctr"/>
           <a:lstStyle/>
           <a:p>
-            <a:pPr indent="0" marL="0">
-              <a:buNone/>
-            </a:pPr>
-            <a:r>
-              <a:rPr lang="en-US" sz="1200" b="1" spc="200" kern="0" dirty="0">
+            <a:pPr marL="0" indent="0">
+              <a:buNone/>
+            </a:pPr>
+            <a:r>
+              <a:rPr lang="en-US" sz="1200" b="1" kern="0" spc="200" dirty="0">
                 <a:solidFill>
                   <a:srgbClr val="2F6F5E"/>
                 </a:solidFill>
@@ -5197,7 +5455,7 @@
           <a:bodyPr wrap="square" lIns="0" tIns="0" rIns="0" bIns="0" rtlCol="0" anchor="ctr"/>
           <a:lstStyle/>
           <a:p>
-            <a:pPr indent="0" marL="0">
+            <a:pPr marL="0" indent="0">
               <a:buNone/>
             </a:pPr>
             <a:r>
@@ -5234,6 +5492,13 @@
           </a:solidFill>
           <a:ln/>
         </p:spPr>
+        <p:txBody>
+          <a:bodyPr/>
+          <a:lstStyle/>
+          <a:p>
+            <a:endParaRPr lang="es-ES"/>
+          </a:p>
+        </p:txBody>
       </p:sp>
       <p:sp>
         <p:nvSpPr>
@@ -5256,7 +5521,7 @@
           <a:bodyPr wrap="square" lIns="0" tIns="0" rIns="0" bIns="0" rtlCol="0" anchor="ctr"/>
           <a:lstStyle/>
           <a:p>
-            <a:pPr algn="ctr" indent="0" marL="0">
+            <a:pPr marL="0" indent="0" algn="ctr">
               <a:buNone/>
             </a:pPr>
             <a:r>
@@ -5295,7 +5560,7 @@
           <a:bodyPr wrap="square" lIns="0" tIns="0" rIns="0" bIns="0" rtlCol="0" anchor="ctr"/>
           <a:lstStyle/>
           <a:p>
-            <a:pPr indent="0" marL="0">
+            <a:pPr marL="0" indent="0">
               <a:buNone/>
             </a:pPr>
             <a:r>
@@ -5334,7 +5599,7 @@
           <a:bodyPr wrap="square" lIns="0" tIns="0" rIns="0" bIns="0" rtlCol="0" anchor="ctr"/>
           <a:lstStyle/>
           <a:p>
-            <a:pPr indent="0" marL="0">
+            <a:pPr marL="0" indent="0">
               <a:buNone/>
             </a:pPr>
             <a:r>
@@ -5371,6 +5636,13 @@
           </a:solidFill>
           <a:ln/>
         </p:spPr>
+        <p:txBody>
+          <a:bodyPr/>
+          <a:lstStyle/>
+          <a:p>
+            <a:endParaRPr lang="es-ES"/>
+          </a:p>
+        </p:txBody>
       </p:sp>
       <p:sp>
         <p:nvSpPr>
@@ -5393,7 +5665,7 @@
           <a:bodyPr wrap="square" lIns="0" tIns="0" rIns="0" bIns="0" rtlCol="0" anchor="ctr"/>
           <a:lstStyle/>
           <a:p>
-            <a:pPr algn="ctr" indent="0" marL="0">
+            <a:pPr marL="0" indent="0" algn="ctr">
               <a:buNone/>
             </a:pPr>
             <a:r>
@@ -5432,7 +5704,7 @@
           <a:bodyPr wrap="square" lIns="0" tIns="0" rIns="0" bIns="0" rtlCol="0" anchor="ctr"/>
           <a:lstStyle/>
           <a:p>
-            <a:pPr indent="0" marL="0">
+            <a:pPr marL="0" indent="0">
               <a:buNone/>
             </a:pPr>
             <a:r>
@@ -5471,7 +5743,7 @@
           <a:bodyPr wrap="square" lIns="0" tIns="0" rIns="0" bIns="0" rtlCol="0" anchor="ctr"/>
           <a:lstStyle/>
           <a:p>
-            <a:pPr indent="0" marL="0">
+            <a:pPr marL="0" indent="0">
               <a:buNone/>
             </a:pPr>
             <a:r>
@@ -5508,6 +5780,13 @@
           </a:solidFill>
           <a:ln/>
         </p:spPr>
+        <p:txBody>
+          <a:bodyPr/>
+          <a:lstStyle/>
+          <a:p>
+            <a:endParaRPr lang="es-ES"/>
+          </a:p>
+        </p:txBody>
       </p:sp>
       <p:sp>
         <p:nvSpPr>
@@ -5530,7 +5809,7 @@
           <a:bodyPr wrap="square" lIns="0" tIns="0" rIns="0" bIns="0" rtlCol="0" anchor="ctr"/>
           <a:lstStyle/>
           <a:p>
-            <a:pPr algn="ctr" indent="0" marL="0">
+            <a:pPr marL="0" indent="0" algn="ctr">
               <a:buNone/>
             </a:pPr>
             <a:r>
@@ -5569,7 +5848,7 @@
           <a:bodyPr wrap="square" lIns="0" tIns="0" rIns="0" bIns="0" rtlCol="0" anchor="ctr"/>
           <a:lstStyle/>
           <a:p>
-            <a:pPr indent="0" marL="0">
+            <a:pPr marL="0" indent="0">
               <a:buNone/>
             </a:pPr>
             <a:r>
@@ -5608,7 +5887,7 @@
           <a:bodyPr wrap="square" lIns="0" tIns="0" rIns="0" bIns="0" rtlCol="0" anchor="ctr"/>
           <a:lstStyle/>
           <a:p>
-            <a:pPr indent="0" marL="0">
+            <a:pPr marL="0" indent="0">
               <a:buNone/>
             </a:pPr>
             <a:r>
@@ -5645,6 +5924,13 @@
           </a:solidFill>
           <a:ln/>
         </p:spPr>
+        <p:txBody>
+          <a:bodyPr/>
+          <a:lstStyle/>
+          <a:p>
+            <a:endParaRPr lang="es-ES"/>
+          </a:p>
+        </p:txBody>
       </p:sp>
       <p:sp>
         <p:nvSpPr>
@@ -5667,7 +5953,7 @@
           <a:bodyPr wrap="square" lIns="0" tIns="0" rIns="0" bIns="0" rtlCol="0" anchor="ctr"/>
           <a:lstStyle/>
           <a:p>
-            <a:pPr algn="ctr" indent="0" marL="0">
+            <a:pPr marL="0" indent="0" algn="ctr">
               <a:buNone/>
             </a:pPr>
             <a:r>
@@ -5706,7 +5992,7 @@
           <a:bodyPr wrap="square" lIns="0" tIns="0" rIns="0" bIns="0" rtlCol="0" anchor="ctr"/>
           <a:lstStyle/>
           <a:p>
-            <a:pPr indent="0" marL="0">
+            <a:pPr marL="0" indent="0">
               <a:buNone/>
             </a:pPr>
             <a:r>
@@ -5745,7 +6031,7 @@
           <a:bodyPr wrap="square" lIns="0" tIns="0" rIns="0" bIns="0" rtlCol="0" anchor="ctr"/>
           <a:lstStyle/>
           <a:p>
-            <a:pPr indent="0" marL="0">
+            <a:pPr marL="0" indent="0">
               <a:buNone/>
             </a:pPr>
             <a:r>
@@ -5782,6 +6068,13 @@
           </a:solidFill>
           <a:ln/>
         </p:spPr>
+        <p:txBody>
+          <a:bodyPr/>
+          <a:lstStyle/>
+          <a:p>
+            <a:endParaRPr lang="es-ES"/>
+          </a:p>
+        </p:txBody>
       </p:sp>
       <p:sp>
         <p:nvSpPr>
@@ -5804,7 +6097,7 @@
           <a:bodyPr wrap="square" lIns="0" tIns="0" rIns="0" bIns="0" rtlCol="0" anchor="ctr"/>
           <a:lstStyle/>
           <a:p>
-            <a:pPr algn="ctr" indent="0" marL="0">
+            <a:pPr marL="0" indent="0" algn="ctr">
               <a:buNone/>
             </a:pPr>
             <a:r>
@@ -5843,7 +6136,7 @@
           <a:bodyPr wrap="square" lIns="0" tIns="0" rIns="0" bIns="0" rtlCol="0" anchor="ctr"/>
           <a:lstStyle/>
           <a:p>
-            <a:pPr indent="0" marL="0">
+            <a:pPr marL="0" indent="0">
               <a:buNone/>
             </a:pPr>
             <a:r>
@@ -5882,7 +6175,7 @@
           <a:bodyPr wrap="square" lIns="0" tIns="0" rIns="0" bIns="0" rtlCol="0" anchor="ctr"/>
           <a:lstStyle/>
           <a:p>
-            <a:pPr indent="0" marL="0">
+            <a:pPr marL="0" indent="0">
               <a:buNone/>
             </a:pPr>
             <a:r>
@@ -5921,7 +6214,7 @@
           <a:bodyPr wrap="square" lIns="0" tIns="0" rIns="0" bIns="0" rtlCol="0" anchor="ctr"/>
           <a:lstStyle/>
           <a:p>
-            <a:pPr algn="r" indent="0" marL="0">
+            <a:pPr marL="0" indent="0" algn="r">
               <a:buNone/>
             </a:pPr>
             <a:r>
@@ -5936,6 +6229,63 @@
               <a:t>02</a:t>
             </a:r>
             <a:endParaRPr lang="en-US" sz="1000" dirty="0"/>
+          </a:p>
+        </p:txBody>
+      </p:sp>
+      <p:sp>
+        <p:nvSpPr>
+          <p:cNvPr id="25" name="Text 3">
+            <a:extLst>
+              <a:ext uri="{FF2B5EF4-FFF2-40B4-BE49-F238E27FC236}">
+                <a16:creationId xmlns:a16="http://schemas.microsoft.com/office/drawing/2014/main" id="{B60DB076-ED6E-49CC-57DB-3E40467224EB}"/>
+              </a:ext>
+            </a:extLst>
+          </p:cNvPr>
+          <p:cNvSpPr/>
+          <p:nvPr/>
+        </p:nvSpPr>
+        <p:spPr>
+          <a:xfrm>
+            <a:off x="9807191" y="6036061"/>
+            <a:ext cx="1788607" cy="457200"/>
+          </a:xfrm>
+          <a:prstGeom prst="rect">
+            <a:avLst/>
+          </a:prstGeom>
+          <a:noFill/>
+          <a:ln/>
+        </p:spPr>
+        <p:txBody>
+          <a:bodyPr wrap="square" lIns="0" tIns="0" rIns="0" bIns="0" rtlCol="0" anchor="ctr"/>
+          <a:lstStyle/>
+          <a:p>
+            <a:pPr marL="0" indent="0">
+              <a:buNone/>
+            </a:pPr>
+            <a:r>
+              <a:rPr lang="en-US" b="1" kern="0" spc="200" dirty="0">
+                <a:solidFill>
+                  <a:srgbClr val="8FD6B8"/>
+                </a:solidFill>
+                <a:latin typeface="Calibri" pitchFamily="34" charset="0"/>
+                <a:ea typeface="Calibri" pitchFamily="34" charset="-122"/>
+                <a:cs typeface="Calibri" pitchFamily="34" charset="-120"/>
+              </a:rPr>
+              <a:t>Link: </a:t>
+            </a:r>
+            <a:r>
+              <a:rPr lang="en-US" b="1" kern="0" spc="200" dirty="0">
+                <a:solidFill>
+                  <a:srgbClr val="8FD6B8"/>
+                </a:solidFill>
+                <a:latin typeface="Calibri" pitchFamily="34" charset="0"/>
+                <a:ea typeface="Calibri" pitchFamily="34" charset="-122"/>
+                <a:cs typeface="Calibri" pitchFamily="34" charset="-120"/>
+                <a:hlinkClick r:id="rId3"/>
+              </a:rPr>
+              <a:t>GitHub</a:t>
+            </a:r>
+            <a:endParaRPr lang="en-US" dirty="0"/>
           </a:p>
         </p:txBody>
       </p:sp>
@@ -5955,6 +6305,7 @@
         <a:solidFill>
           <a:srgbClr val="F7F8F5"/>
         </a:solidFill>
+        <a:effectLst/>
       </p:bgPr>
     </p:bg>
     <p:spTree>
@@ -5992,11 +6343,11 @@
           <a:bodyPr wrap="square" lIns="0" tIns="0" rIns="0" bIns="0" rtlCol="0" anchor="ctr"/>
           <a:lstStyle/>
           <a:p>
-            <a:pPr indent="0" marL="0">
-              <a:buNone/>
-            </a:pPr>
-            <a:r>
-              <a:rPr lang="en-US" sz="1200" b="1" spc="200" kern="0" dirty="0">
+            <a:pPr marL="0" indent="0">
+              <a:buNone/>
+            </a:pPr>
+            <a:r>
+              <a:rPr lang="en-US" sz="1200" b="1" kern="0" spc="200" dirty="0">
                 <a:solidFill>
                   <a:srgbClr val="2F6F5E"/>
                 </a:solidFill>
@@ -6031,7 +6382,7 @@
           <a:bodyPr wrap="square" lIns="0" tIns="0" rIns="0" bIns="0" rtlCol="0" anchor="ctr"/>
           <a:lstStyle/>
           <a:p>
-            <a:pPr indent="0" marL="0">
+            <a:pPr marL="0" indent="0">
               <a:lnSpc>
                 <a:spcPts val="3400"/>
               </a:lnSpc>
@@ -6051,7 +6402,7 @@
             <a:endParaRPr lang="en-US" sz="3000" dirty="0"/>
           </a:p>
           <a:p>
-            <a:pPr indent="0" marL="0">
+            <a:pPr marL="0" indent="0">
               <a:lnSpc>
                 <a:spcPts val="3400"/>
               </a:lnSpc>
@@ -6098,6 +6449,13 @@
             <a:prstDash val="solid"/>
           </a:ln>
         </p:spPr>
+        <p:txBody>
+          <a:bodyPr/>
+          <a:lstStyle/>
+          <a:p>
+            <a:endParaRPr lang="es-ES"/>
+          </a:p>
+        </p:txBody>
       </p:sp>
       <p:sp>
         <p:nvSpPr>
@@ -6118,6 +6476,13 @@
           </a:solidFill>
           <a:ln/>
         </p:spPr>
+        <p:txBody>
+          <a:bodyPr/>
+          <a:lstStyle/>
+          <a:p>
+            <a:endParaRPr lang="es-ES"/>
+          </a:p>
+        </p:txBody>
       </p:sp>
       <p:sp>
         <p:nvSpPr>
@@ -6140,7 +6505,7 @@
           <a:bodyPr wrap="square" lIns="0" tIns="0" rIns="0" bIns="0" rtlCol="0" anchor="ctr"/>
           <a:lstStyle/>
           <a:p>
-            <a:pPr algn="ctr" indent="0" marL="0">
+            <a:pPr marL="0" indent="0" algn="ctr">
               <a:buNone/>
             </a:pPr>
             <a:r>
@@ -6179,7 +6544,7 @@
           <a:bodyPr wrap="square" lIns="0" tIns="0" rIns="0" bIns="0" rtlCol="0" anchor="ctr"/>
           <a:lstStyle/>
           <a:p>
-            <a:pPr indent="0" marL="0">
+            <a:pPr marL="0" indent="0">
               <a:buNone/>
             </a:pPr>
             <a:r>
@@ -6218,7 +6583,7 @@
           <a:bodyPr wrap="square" lIns="0" tIns="0" rIns="0" bIns="0" rtlCol="0" anchor="ctr"/>
           <a:lstStyle/>
           <a:p>
-            <a:pPr indent="0" marL="0">
+            <a:pPr marL="0" indent="0">
               <a:lnSpc>
                 <a:spcPts val="1600"/>
               </a:lnSpc>
@@ -6265,6 +6630,13 @@
             <a:prstDash val="solid"/>
           </a:ln>
         </p:spPr>
+        <p:txBody>
+          <a:bodyPr/>
+          <a:lstStyle/>
+          <a:p>
+            <a:endParaRPr lang="es-ES"/>
+          </a:p>
+        </p:txBody>
       </p:sp>
       <p:sp>
         <p:nvSpPr>
@@ -6285,6 +6657,13 @@
           </a:solidFill>
           <a:ln/>
         </p:spPr>
+        <p:txBody>
+          <a:bodyPr/>
+          <a:lstStyle/>
+          <a:p>
+            <a:endParaRPr lang="es-ES"/>
+          </a:p>
+        </p:txBody>
       </p:sp>
       <p:sp>
         <p:nvSpPr>
@@ -6307,7 +6686,7 @@
           <a:bodyPr wrap="square" lIns="0" tIns="0" rIns="0" bIns="0" rtlCol="0" anchor="ctr"/>
           <a:lstStyle/>
           <a:p>
-            <a:pPr algn="ctr" indent="0" marL="0">
+            <a:pPr marL="0" indent="0" algn="ctr">
               <a:buNone/>
             </a:pPr>
             <a:r>
@@ -6346,7 +6725,7 @@
           <a:bodyPr wrap="square" lIns="0" tIns="0" rIns="0" bIns="0" rtlCol="0" anchor="ctr"/>
           <a:lstStyle/>
           <a:p>
-            <a:pPr indent="0" marL="0">
+            <a:pPr marL="0" indent="0">
               <a:buNone/>
             </a:pPr>
             <a:r>
@@ -6385,7 +6764,7 @@
           <a:bodyPr wrap="square" lIns="0" tIns="0" rIns="0" bIns="0" rtlCol="0" anchor="ctr"/>
           <a:lstStyle/>
           <a:p>
-            <a:pPr indent="0" marL="0">
+            <a:pPr marL="0" indent="0">
               <a:lnSpc>
                 <a:spcPts val="1600"/>
               </a:lnSpc>
@@ -6432,6 +6811,13 @@
             <a:prstDash val="solid"/>
           </a:ln>
         </p:spPr>
+        <p:txBody>
+          <a:bodyPr/>
+          <a:lstStyle/>
+          <a:p>
+            <a:endParaRPr lang="es-ES"/>
+          </a:p>
+        </p:txBody>
       </p:sp>
       <p:sp>
         <p:nvSpPr>
@@ -6452,6 +6838,13 @@
           </a:solidFill>
           <a:ln/>
         </p:spPr>
+        <p:txBody>
+          <a:bodyPr/>
+          <a:lstStyle/>
+          <a:p>
+            <a:endParaRPr lang="es-ES"/>
+          </a:p>
+        </p:txBody>
       </p:sp>
       <p:sp>
         <p:nvSpPr>
@@ -6474,7 +6867,7 @@
           <a:bodyPr wrap="square" lIns="0" tIns="0" rIns="0" bIns="0" rtlCol="0" anchor="ctr"/>
           <a:lstStyle/>
           <a:p>
-            <a:pPr algn="ctr" indent="0" marL="0">
+            <a:pPr marL="0" indent="0" algn="ctr">
               <a:buNone/>
             </a:pPr>
             <a:r>
@@ -6513,7 +6906,7 @@
           <a:bodyPr wrap="square" lIns="0" tIns="0" rIns="0" bIns="0" rtlCol="0" anchor="ctr"/>
           <a:lstStyle/>
           <a:p>
-            <a:pPr indent="0" marL="0">
+            <a:pPr marL="0" indent="0">
               <a:buNone/>
             </a:pPr>
             <a:r>
@@ -6552,7 +6945,7 @@
           <a:bodyPr wrap="square" lIns="0" tIns="0" rIns="0" bIns="0" rtlCol="0" anchor="ctr"/>
           <a:lstStyle/>
           <a:p>
-            <a:pPr indent="0" marL="0">
+            <a:pPr marL="0" indent="0">
               <a:lnSpc>
                 <a:spcPts val="1600"/>
               </a:lnSpc>
@@ -6594,7 +6987,7 @@
           <a:bodyPr wrap="square" lIns="0" tIns="0" rIns="0" bIns="0" rtlCol="0" anchor="ctr"/>
           <a:lstStyle/>
           <a:p>
-            <a:pPr algn="r" indent="0" marL="0">
+            <a:pPr marL="0" indent="0" algn="r">
               <a:buNone/>
             </a:pPr>
             <a:r>
@@ -6609,6 +7002,63 @@
               <a:t>03</a:t>
             </a:r>
             <a:endParaRPr lang="en-US" sz="1000" dirty="0"/>
+          </a:p>
+        </p:txBody>
+      </p:sp>
+      <p:sp>
+        <p:nvSpPr>
+          <p:cNvPr id="20" name="Text 3">
+            <a:extLst>
+              <a:ext uri="{FF2B5EF4-FFF2-40B4-BE49-F238E27FC236}">
+                <a16:creationId xmlns:a16="http://schemas.microsoft.com/office/drawing/2014/main" id="{F43749DB-F3DF-13F9-8509-411A7866451D}"/>
+              </a:ext>
+            </a:extLst>
+          </p:cNvPr>
+          <p:cNvSpPr/>
+          <p:nvPr/>
+        </p:nvSpPr>
+        <p:spPr>
+          <a:xfrm>
+            <a:off x="9807191" y="6036061"/>
+            <a:ext cx="1788607" cy="457200"/>
+          </a:xfrm>
+          <a:prstGeom prst="rect">
+            <a:avLst/>
+          </a:prstGeom>
+          <a:noFill/>
+          <a:ln/>
+        </p:spPr>
+        <p:txBody>
+          <a:bodyPr wrap="square" lIns="0" tIns="0" rIns="0" bIns="0" rtlCol="0" anchor="ctr"/>
+          <a:lstStyle/>
+          <a:p>
+            <a:pPr marL="0" indent="0">
+              <a:buNone/>
+            </a:pPr>
+            <a:r>
+              <a:rPr lang="en-US" b="1" kern="0" spc="200" dirty="0">
+                <a:solidFill>
+                  <a:srgbClr val="8FD6B8"/>
+                </a:solidFill>
+                <a:latin typeface="Calibri" pitchFamily="34" charset="0"/>
+                <a:ea typeface="Calibri" pitchFamily="34" charset="-122"/>
+                <a:cs typeface="Calibri" pitchFamily="34" charset="-120"/>
+              </a:rPr>
+              <a:t>Link: </a:t>
+            </a:r>
+            <a:r>
+              <a:rPr lang="en-US" b="1" kern="0" spc="200" dirty="0">
+                <a:solidFill>
+                  <a:srgbClr val="8FD6B8"/>
+                </a:solidFill>
+                <a:latin typeface="Calibri" pitchFamily="34" charset="0"/>
+                <a:ea typeface="Calibri" pitchFamily="34" charset="-122"/>
+                <a:cs typeface="Calibri" pitchFamily="34" charset="-120"/>
+                <a:hlinkClick r:id="rId3"/>
+              </a:rPr>
+              <a:t>GitHub</a:t>
+            </a:r>
+            <a:endParaRPr lang="en-US" dirty="0"/>
           </a:p>
         </p:txBody>
       </p:sp>
@@ -6628,6 +7078,7 @@
         <a:solidFill>
           <a:srgbClr val="16211D"/>
         </a:solidFill>
+        <a:effectLst/>
       </p:bgPr>
     </p:bg>
     <p:spTree>
@@ -6665,11 +7116,11 @@
           <a:bodyPr wrap="square" lIns="0" tIns="0" rIns="0" bIns="0" rtlCol="0" anchor="ctr"/>
           <a:lstStyle/>
           <a:p>
-            <a:pPr indent="0" marL="0">
-              <a:buNone/>
-            </a:pPr>
-            <a:r>
-              <a:rPr lang="en-US" sz="1200" b="1" spc="200" kern="0" dirty="0">
+            <a:pPr marL="0" indent="0">
+              <a:buNone/>
+            </a:pPr>
+            <a:r>
+              <a:rPr lang="en-US" sz="1200" b="1" kern="0" spc="200" dirty="0">
                 <a:solidFill>
                   <a:srgbClr val="8FD6B8"/>
                 </a:solidFill>
@@ -6704,7 +7155,7 @@
           <a:bodyPr wrap="square" lIns="0" tIns="0" rIns="0" bIns="0" rtlCol="0" anchor="ctr"/>
           <a:lstStyle/>
           <a:p>
-            <a:pPr indent="0" marL="0">
+            <a:pPr marL="0" indent="0">
               <a:buNone/>
             </a:pPr>
             <a:r>
@@ -6743,7 +7194,7 @@
           <a:bodyPr wrap="square" lIns="0" tIns="0" rIns="0" bIns="0" rtlCol="0" anchor="ctr"/>
           <a:lstStyle/>
           <a:p>
-            <a:pPr indent="0" marL="0">
+            <a:pPr marL="0" indent="0">
               <a:buNone/>
             </a:pPr>
             <a:r>
@@ -6782,7 +7233,7 @@
           <a:bodyPr wrap="square" lIns="0" tIns="0" rIns="0" bIns="0" rtlCol="0" anchor="ctr"/>
           <a:lstStyle/>
           <a:p>
-            <a:pPr indent="0" marL="0">
+            <a:pPr marL="0" indent="0">
               <a:lnSpc>
                 <a:spcPts val="2200"/>
               </a:lnSpc>
@@ -6829,6 +7280,13 @@
             <a:prstDash val="solid"/>
           </a:ln>
         </p:spPr>
+        <p:txBody>
+          <a:bodyPr/>
+          <a:lstStyle/>
+          <a:p>
+            <a:endParaRPr lang="es-ES"/>
+          </a:p>
+        </p:txBody>
       </p:sp>
       <p:sp>
         <p:nvSpPr>
@@ -6851,7 +7309,7 @@
           <a:bodyPr wrap="square" lIns="0" tIns="0" rIns="0" bIns="0" rtlCol="0" anchor="ctr"/>
           <a:lstStyle/>
           <a:p>
-            <a:pPr indent="0" marL="0">
+            <a:pPr marL="0" indent="0">
               <a:buNone/>
             </a:pPr>
             <a:r>
@@ -6895,6 +7353,13 @@
             <a:prstDash val="solid"/>
           </a:ln>
         </p:spPr>
+        <p:txBody>
+          <a:bodyPr/>
+          <a:lstStyle/>
+          <a:p>
+            <a:endParaRPr lang="es-ES"/>
+          </a:p>
+        </p:txBody>
       </p:sp>
       <p:sp>
         <p:nvSpPr>
@@ -6917,7 +7382,7 @@
           <a:bodyPr wrap="square" lIns="0" tIns="0" rIns="0" bIns="0" rtlCol="0" anchor="ctr"/>
           <a:lstStyle/>
           <a:p>
-            <a:pPr indent="0" marL="0">
+            <a:pPr marL="0" indent="0">
               <a:buNone/>
             </a:pPr>
             <a:r>
@@ -6956,7 +7421,7 @@
           <a:bodyPr wrap="square" lIns="0" tIns="0" rIns="0" bIns="0" rtlCol="0" anchor="ctr"/>
           <a:lstStyle/>
           <a:p>
-            <a:pPr indent="0" marL="0">
+            <a:pPr marL="0" indent="0">
               <a:buNone/>
             </a:pPr>
             <a:r>
@@ -6995,6 +7460,13 @@
           </a:solidFill>
           <a:ln/>
         </p:spPr>
+        <p:txBody>
+          <a:bodyPr/>
+          <a:lstStyle/>
+          <a:p>
+            <a:endParaRPr lang="es-ES"/>
+          </a:p>
+        </p:txBody>
       </p:sp>
       <p:sp>
         <p:nvSpPr>
@@ -7017,7 +7489,7 @@
           <a:bodyPr wrap="square" lIns="0" tIns="0" rIns="0" bIns="0" rtlCol="0" anchor="ctr"/>
           <a:lstStyle/>
           <a:p>
-            <a:pPr indent="0" marL="0">
+            <a:pPr marL="0" indent="0">
               <a:buNone/>
             </a:pPr>
             <a:r>
@@ -7056,7 +7528,7 @@
           <a:bodyPr wrap="square" lIns="0" tIns="0" rIns="0" bIns="0" rtlCol="0" anchor="ctr"/>
           <a:lstStyle/>
           <a:p>
-            <a:pPr indent="0" marL="0">
+            <a:pPr marL="0" indent="0">
               <a:lnSpc>
                 <a:spcPts val="1600"/>
               </a:lnSpc>
@@ -7076,7 +7548,7 @@
             <a:endParaRPr lang="en-US" sz="1100" dirty="0"/>
           </a:p>
           <a:p>
-            <a:pPr indent="0" marL="0">
+            <a:pPr marL="0" indent="0">
               <a:lnSpc>
                 <a:spcPts val="1600"/>
               </a:lnSpc>
@@ -7096,7 +7568,7 @@
             <a:endParaRPr lang="en-US" sz="1100" dirty="0"/>
           </a:p>
           <a:p>
-            <a:pPr indent="0" marL="0">
+            <a:pPr marL="0" indent="0">
               <a:lnSpc>
                 <a:spcPts val="1600"/>
               </a:lnSpc>
@@ -7116,7 +7588,7 @@
             <a:endParaRPr lang="en-US" sz="1100" dirty="0"/>
           </a:p>
           <a:p>
-            <a:pPr indent="0" marL="0">
+            <a:pPr marL="0" indent="0">
               <a:lnSpc>
                 <a:spcPts val="1600"/>
               </a:lnSpc>
@@ -7136,7 +7608,7 @@
             <a:endParaRPr lang="en-US" sz="1100" dirty="0"/>
           </a:p>
           <a:p>
-            <a:pPr indent="0" marL="0">
+            <a:pPr marL="0" indent="0">
               <a:lnSpc>
                 <a:spcPts val="1600"/>
               </a:lnSpc>
@@ -7156,7 +7628,7 @@
             <a:endParaRPr lang="en-US" sz="1100" dirty="0"/>
           </a:p>
           <a:p>
-            <a:pPr indent="0" marL="0">
+            <a:pPr marL="0" indent="0">
               <a:lnSpc>
                 <a:spcPts val="1600"/>
               </a:lnSpc>
@@ -7198,7 +7670,7 @@
           <a:bodyPr wrap="square" lIns="0" tIns="0" rIns="0" bIns="0" rtlCol="0" anchor="ctr"/>
           <a:lstStyle/>
           <a:p>
-            <a:pPr algn="r" indent="0" marL="0">
+            <a:pPr marL="0" indent="0" algn="r">
               <a:buNone/>
             </a:pPr>
             <a:r>
@@ -7213,6 +7685,63 @@
               <a:t>04</a:t>
             </a:r>
             <a:endParaRPr lang="en-US" sz="1000" dirty="0"/>
+          </a:p>
+        </p:txBody>
+      </p:sp>
+      <p:sp>
+        <p:nvSpPr>
+          <p:cNvPr id="15" name="Text 3">
+            <a:extLst>
+              <a:ext uri="{FF2B5EF4-FFF2-40B4-BE49-F238E27FC236}">
+                <a16:creationId xmlns:a16="http://schemas.microsoft.com/office/drawing/2014/main" id="{D0FBE22B-B784-E163-8A7F-F08140AC47EF}"/>
+              </a:ext>
+            </a:extLst>
+          </p:cNvPr>
+          <p:cNvSpPr/>
+          <p:nvPr/>
+        </p:nvSpPr>
+        <p:spPr>
+          <a:xfrm>
+            <a:off x="9807191" y="6036061"/>
+            <a:ext cx="1788607" cy="457200"/>
+          </a:xfrm>
+          <a:prstGeom prst="rect">
+            <a:avLst/>
+          </a:prstGeom>
+          <a:noFill/>
+          <a:ln/>
+        </p:spPr>
+        <p:txBody>
+          <a:bodyPr wrap="square" lIns="0" tIns="0" rIns="0" bIns="0" rtlCol="0" anchor="ctr"/>
+          <a:lstStyle/>
+          <a:p>
+            <a:pPr marL="0" indent="0">
+              <a:buNone/>
+            </a:pPr>
+            <a:r>
+              <a:rPr lang="en-US" b="1" kern="0" spc="200" dirty="0">
+                <a:solidFill>
+                  <a:srgbClr val="8FD6B8"/>
+                </a:solidFill>
+                <a:latin typeface="Calibri" pitchFamily="34" charset="0"/>
+                <a:ea typeface="Calibri" pitchFamily="34" charset="-122"/>
+                <a:cs typeface="Calibri" pitchFamily="34" charset="-120"/>
+              </a:rPr>
+              <a:t>Link: </a:t>
+            </a:r>
+            <a:r>
+              <a:rPr lang="en-US" b="1" kern="0" spc="200" dirty="0">
+                <a:solidFill>
+                  <a:srgbClr val="8FD6B8"/>
+                </a:solidFill>
+                <a:latin typeface="Calibri" pitchFamily="34" charset="0"/>
+                <a:ea typeface="Calibri" pitchFamily="34" charset="-122"/>
+                <a:cs typeface="Calibri" pitchFamily="34" charset="-120"/>
+                <a:hlinkClick r:id="rId3"/>
+              </a:rPr>
+              <a:t>GitHub</a:t>
+            </a:r>
+            <a:endParaRPr lang="en-US" dirty="0"/>
           </a:p>
         </p:txBody>
       </p:sp>
@@ -7232,6 +7761,7 @@
         <a:solidFill>
           <a:srgbClr val="F7F8F5"/>
         </a:solidFill>
+        <a:effectLst/>
       </p:bgPr>
     </p:bg>
     <p:spTree>
@@ -7269,11 +7799,11 @@
           <a:bodyPr wrap="square" lIns="0" tIns="0" rIns="0" bIns="0" rtlCol="0" anchor="ctr"/>
           <a:lstStyle/>
           <a:p>
-            <a:pPr indent="0" marL="0">
-              <a:buNone/>
-            </a:pPr>
-            <a:r>
-              <a:rPr lang="en-US" sz="1200" b="1" spc="200" kern="0" dirty="0">
+            <a:pPr marL="0" indent="0">
+              <a:buNone/>
+            </a:pPr>
+            <a:r>
+              <a:rPr lang="en-US" sz="1200" b="1" kern="0" spc="200" dirty="0">
                 <a:solidFill>
                   <a:srgbClr val="2F6F5E"/>
                 </a:solidFill>
@@ -7308,7 +7838,7 @@
           <a:bodyPr wrap="square" lIns="0" tIns="0" rIns="0" bIns="0" rtlCol="0" anchor="ctr"/>
           <a:lstStyle/>
           <a:p>
-            <a:pPr indent="0" marL="0">
+            <a:pPr marL="0" indent="0">
               <a:buNone/>
             </a:pPr>
             <a:r>
@@ -7347,7 +7877,7 @@
           <a:bodyPr wrap="square" lIns="0" tIns="0" rIns="0" bIns="0" rtlCol="0" anchor="ctr"/>
           <a:lstStyle/>
           <a:p>
-            <a:pPr indent="0" marL="0">
+            <a:pPr marL="0" indent="0">
               <a:lnSpc>
                 <a:spcPts val="1900"/>
               </a:lnSpc>
@@ -7394,6 +7924,13 @@
             <a:prstDash val="solid"/>
           </a:ln>
         </p:spPr>
+        <p:txBody>
+          <a:bodyPr/>
+          <a:lstStyle/>
+          <a:p>
+            <a:endParaRPr lang="es-ES"/>
+          </a:p>
+        </p:txBody>
       </p:sp>
       <p:sp>
         <p:nvSpPr>
@@ -7416,7 +7953,7 @@
           <a:bodyPr wrap="square" lIns="0" tIns="0" rIns="0" bIns="0" rtlCol="0" anchor="ctr"/>
           <a:lstStyle/>
           <a:p>
-            <a:pPr indent="0" marL="0">
+            <a:pPr marL="0" indent="0">
               <a:buNone/>
             </a:pPr>
             <a:r>
@@ -7455,7 +7992,7 @@
           <a:bodyPr wrap="square" lIns="0" tIns="0" rIns="0" bIns="0" rtlCol="0" anchor="ctr"/>
           <a:lstStyle/>
           <a:p>
-            <a:pPr indent="0" marL="0">
+            <a:pPr marL="0" indent="0">
               <a:lnSpc>
                 <a:spcPts val="1500"/>
               </a:lnSpc>
@@ -7502,6 +8039,13 @@
             <a:prstDash val="solid"/>
           </a:ln>
         </p:spPr>
+        <p:txBody>
+          <a:bodyPr/>
+          <a:lstStyle/>
+          <a:p>
+            <a:endParaRPr lang="es-ES"/>
+          </a:p>
+        </p:txBody>
       </p:sp>
       <p:sp>
         <p:nvSpPr>
@@ -7524,7 +8068,7 @@
           <a:bodyPr wrap="square" lIns="0" tIns="0" rIns="0" bIns="0" rtlCol="0" anchor="ctr"/>
           <a:lstStyle/>
           <a:p>
-            <a:pPr indent="0" marL="0">
+            <a:pPr marL="0" indent="0">
               <a:buNone/>
             </a:pPr>
             <a:r>
@@ -7563,7 +8107,7 @@
           <a:bodyPr wrap="square" lIns="0" tIns="0" rIns="0" bIns="0" rtlCol="0" anchor="ctr"/>
           <a:lstStyle/>
           <a:p>
-            <a:pPr indent="0" marL="0">
+            <a:pPr marL="0" indent="0">
               <a:lnSpc>
                 <a:spcPts val="1500"/>
               </a:lnSpc>
@@ -7610,6 +8154,13 @@
             <a:prstDash val="solid"/>
           </a:ln>
         </p:spPr>
+        <p:txBody>
+          <a:bodyPr/>
+          <a:lstStyle/>
+          <a:p>
+            <a:endParaRPr lang="es-ES"/>
+          </a:p>
+        </p:txBody>
       </p:sp>
       <p:sp>
         <p:nvSpPr>
@@ -7632,7 +8183,7 @@
           <a:bodyPr wrap="square" lIns="0" tIns="0" rIns="0" bIns="0" rtlCol="0" anchor="ctr"/>
           <a:lstStyle/>
           <a:p>
-            <a:pPr indent="0" marL="0">
+            <a:pPr marL="0" indent="0">
               <a:buNone/>
             </a:pPr>
             <a:r>
@@ -7671,7 +8222,7 @@
           <a:bodyPr wrap="square" lIns="0" tIns="0" rIns="0" bIns="0" rtlCol="0" anchor="ctr"/>
           <a:lstStyle/>
           <a:p>
-            <a:pPr indent="0" marL="0">
+            <a:pPr marL="0" indent="0">
               <a:lnSpc>
                 <a:spcPts val="1500"/>
               </a:lnSpc>
@@ -7718,6 +8269,13 @@
             <a:prstDash val="solid"/>
           </a:ln>
         </p:spPr>
+        <p:txBody>
+          <a:bodyPr/>
+          <a:lstStyle/>
+          <a:p>
+            <a:endParaRPr lang="es-ES"/>
+          </a:p>
+        </p:txBody>
       </p:sp>
       <p:sp>
         <p:nvSpPr>
@@ -7740,7 +8298,7 @@
           <a:bodyPr wrap="square" lIns="0" tIns="0" rIns="0" bIns="0" rtlCol="0" anchor="ctr"/>
           <a:lstStyle/>
           <a:p>
-            <a:pPr indent="0" marL="0">
+            <a:pPr marL="0" indent="0">
               <a:buNone/>
             </a:pPr>
             <a:r>
@@ -7779,7 +8337,7 @@
           <a:bodyPr wrap="square" lIns="0" tIns="0" rIns="0" bIns="0" rtlCol="0" anchor="ctr"/>
           <a:lstStyle/>
           <a:p>
-            <a:pPr indent="0" marL="0">
+            <a:pPr marL="0" indent="0">
               <a:lnSpc>
                 <a:spcPts val="1500"/>
               </a:lnSpc>
@@ -7826,6 +8384,13 @@
             <a:prstDash val="solid"/>
           </a:ln>
         </p:spPr>
+        <p:txBody>
+          <a:bodyPr/>
+          <a:lstStyle/>
+          <a:p>
+            <a:endParaRPr lang="es-ES"/>
+          </a:p>
+        </p:txBody>
       </p:sp>
       <p:sp>
         <p:nvSpPr>
@@ -7848,7 +8413,7 @@
           <a:bodyPr wrap="square" lIns="0" tIns="0" rIns="0" bIns="0" rtlCol="0" anchor="ctr"/>
           <a:lstStyle/>
           <a:p>
-            <a:pPr indent="0" marL="0">
+            <a:pPr marL="0" indent="0">
               <a:buNone/>
             </a:pPr>
             <a:r>
@@ -7887,7 +8452,7 @@
           <a:bodyPr wrap="square" lIns="0" tIns="0" rIns="0" bIns="0" rtlCol="0" anchor="ctr"/>
           <a:lstStyle/>
           <a:p>
-            <a:pPr indent="0" marL="0">
+            <a:pPr marL="0" indent="0">
               <a:lnSpc>
                 <a:spcPts val="1500"/>
               </a:lnSpc>
@@ -7934,6 +8499,13 @@
             <a:prstDash val="solid"/>
           </a:ln>
         </p:spPr>
+        <p:txBody>
+          <a:bodyPr/>
+          <a:lstStyle/>
+          <a:p>
+            <a:endParaRPr lang="es-ES"/>
+          </a:p>
+        </p:txBody>
       </p:sp>
       <p:sp>
         <p:nvSpPr>
@@ -7956,7 +8528,7 @@
           <a:bodyPr wrap="square" lIns="0" tIns="0" rIns="0" bIns="0" rtlCol="0" anchor="ctr"/>
           <a:lstStyle/>
           <a:p>
-            <a:pPr indent="0" marL="0">
+            <a:pPr marL="0" indent="0">
               <a:buNone/>
             </a:pPr>
             <a:r>
@@ -7995,7 +8567,7 @@
           <a:bodyPr wrap="square" lIns="0" tIns="0" rIns="0" bIns="0" rtlCol="0" anchor="ctr"/>
           <a:lstStyle/>
           <a:p>
-            <a:pPr indent="0" marL="0">
+            <a:pPr marL="0" indent="0">
               <a:lnSpc>
                 <a:spcPts val="1500"/>
               </a:lnSpc>
@@ -8037,7 +8609,7 @@
           <a:bodyPr wrap="square" lIns="0" tIns="0" rIns="0" bIns="0" rtlCol="0" anchor="ctr"/>
           <a:lstStyle/>
           <a:p>
-            <a:pPr algn="r" indent="0" marL="0">
+            <a:pPr marL="0" indent="0" algn="r">
               <a:buNone/>
             </a:pPr>
             <a:r>
@@ -8052,6 +8624,63 @@
               <a:t>05</a:t>
             </a:r>
             <a:endParaRPr lang="en-US" sz="1000" dirty="0"/>
+          </a:p>
+        </p:txBody>
+      </p:sp>
+      <p:sp>
+        <p:nvSpPr>
+          <p:cNvPr id="24" name="Text 3">
+            <a:extLst>
+              <a:ext uri="{FF2B5EF4-FFF2-40B4-BE49-F238E27FC236}">
+                <a16:creationId xmlns:a16="http://schemas.microsoft.com/office/drawing/2014/main" id="{D7CE1525-A250-7285-6C70-92A64E55A3B7}"/>
+              </a:ext>
+            </a:extLst>
+          </p:cNvPr>
+          <p:cNvSpPr/>
+          <p:nvPr/>
+        </p:nvSpPr>
+        <p:spPr>
+          <a:xfrm>
+            <a:off x="9807191" y="6036061"/>
+            <a:ext cx="1788607" cy="457200"/>
+          </a:xfrm>
+          <a:prstGeom prst="rect">
+            <a:avLst/>
+          </a:prstGeom>
+          <a:noFill/>
+          <a:ln/>
+        </p:spPr>
+        <p:txBody>
+          <a:bodyPr wrap="square" lIns="0" tIns="0" rIns="0" bIns="0" rtlCol="0" anchor="ctr"/>
+          <a:lstStyle/>
+          <a:p>
+            <a:pPr marL="0" indent="0">
+              <a:buNone/>
+            </a:pPr>
+            <a:r>
+              <a:rPr lang="en-US" b="1" kern="0" spc="200" dirty="0">
+                <a:solidFill>
+                  <a:srgbClr val="8FD6B8"/>
+                </a:solidFill>
+                <a:latin typeface="Calibri" pitchFamily="34" charset="0"/>
+                <a:ea typeface="Calibri" pitchFamily="34" charset="-122"/>
+                <a:cs typeface="Calibri" pitchFamily="34" charset="-120"/>
+              </a:rPr>
+              <a:t>Link: </a:t>
+            </a:r>
+            <a:r>
+              <a:rPr lang="en-US" b="1" kern="0" spc="200" dirty="0">
+                <a:solidFill>
+                  <a:srgbClr val="8FD6B8"/>
+                </a:solidFill>
+                <a:latin typeface="Calibri" pitchFamily="34" charset="0"/>
+                <a:ea typeface="Calibri" pitchFamily="34" charset="-122"/>
+                <a:cs typeface="Calibri" pitchFamily="34" charset="-120"/>
+                <a:hlinkClick r:id="rId3"/>
+              </a:rPr>
+              <a:t>GitHub</a:t>
+            </a:r>
+            <a:endParaRPr lang="en-US" dirty="0"/>
           </a:p>
         </p:txBody>
       </p:sp>
@@ -8071,6 +8700,7 @@
         <a:solidFill>
           <a:srgbClr val="F7F8F5"/>
         </a:solidFill>
+        <a:effectLst/>
       </p:bgPr>
     </p:bg>
     <p:spTree>
@@ -8108,11 +8738,11 @@
           <a:bodyPr wrap="square" lIns="0" tIns="0" rIns="0" bIns="0" rtlCol="0" anchor="ctr"/>
           <a:lstStyle/>
           <a:p>
-            <a:pPr indent="0" marL="0">
-              <a:buNone/>
-            </a:pPr>
-            <a:r>
-              <a:rPr lang="en-US" sz="1200" b="1" spc="200" kern="0" dirty="0">
+            <a:pPr marL="0" indent="0">
+              <a:buNone/>
+            </a:pPr>
+            <a:r>
+              <a:rPr lang="en-US" sz="1200" b="1" kern="0" spc="200" dirty="0">
                 <a:solidFill>
                   <a:srgbClr val="2F6F5E"/>
                 </a:solidFill>
@@ -8147,7 +8777,7 @@
           <a:bodyPr wrap="square" lIns="0" tIns="0" rIns="0" bIns="0" rtlCol="0" anchor="ctr"/>
           <a:lstStyle/>
           <a:p>
-            <a:pPr indent="0" marL="0">
+            <a:pPr marL="0" indent="0">
               <a:buNone/>
             </a:pPr>
             <a:r>
@@ -8186,6 +8816,13 @@
           </a:solidFill>
           <a:ln/>
         </p:spPr>
+        <p:txBody>
+          <a:bodyPr/>
+          <a:lstStyle/>
+          <a:p>
+            <a:endParaRPr lang="es-ES"/>
+          </a:p>
+        </p:txBody>
       </p:sp>
       <p:sp>
         <p:nvSpPr>
@@ -8208,7 +8845,7 @@
           <a:bodyPr wrap="square" lIns="0" tIns="0" rIns="0" bIns="0" rtlCol="0" anchor="ctr"/>
           <a:lstStyle/>
           <a:p>
-            <a:pPr indent="0" marL="0">
+            <a:pPr marL="0" indent="0">
               <a:buNone/>
             </a:pPr>
             <a:r>
@@ -8247,7 +8884,7 @@
           <a:bodyPr wrap="square" lIns="0" tIns="0" rIns="0" bIns="0" rtlCol="0" anchor="ctr"/>
           <a:lstStyle/>
           <a:p>
-            <a:pPr indent="0" marL="0">
+            <a:pPr marL="0" indent="0">
               <a:lnSpc>
                 <a:spcPts val="1800"/>
               </a:lnSpc>
@@ -8289,7 +8926,7 @@
           <a:bodyPr wrap="square" lIns="0" tIns="0" rIns="0" bIns="0" rtlCol="0" anchor="ctr"/>
           <a:lstStyle/>
           <a:p>
-            <a:pPr indent="0" marL="0">
+            <a:pPr marL="0" indent="0">
               <a:lnSpc>
                 <a:spcPts val="1500"/>
               </a:lnSpc>
@@ -8331,7 +8968,7 @@
           <a:bodyPr wrap="square" lIns="0" tIns="0" rIns="0" bIns="0" rtlCol="0" anchor="ctr"/>
           <a:lstStyle/>
           <a:p>
-            <a:pPr algn="ctr" indent="0" marL="0">
+            <a:pPr marL="0" indent="0" algn="ctr">
               <a:buNone/>
             </a:pPr>
             <a:r>
@@ -8370,6 +9007,13 @@
           </a:solidFill>
           <a:ln/>
         </p:spPr>
+        <p:txBody>
+          <a:bodyPr/>
+          <a:lstStyle/>
+          <a:p>
+            <a:endParaRPr lang="es-ES"/>
+          </a:p>
+        </p:txBody>
       </p:sp>
       <p:sp>
         <p:nvSpPr>
@@ -8392,7 +9036,7 @@
           <a:bodyPr wrap="square" lIns="0" tIns="0" rIns="0" bIns="0" rtlCol="0" anchor="ctr"/>
           <a:lstStyle/>
           <a:p>
-            <a:pPr indent="0" marL="0">
+            <a:pPr marL="0" indent="0">
               <a:buNone/>
             </a:pPr>
             <a:r>
@@ -8431,7 +9075,7 @@
           <a:bodyPr wrap="square" lIns="0" tIns="0" rIns="0" bIns="0" rtlCol="0" anchor="ctr"/>
           <a:lstStyle/>
           <a:p>
-            <a:pPr indent="0" marL="0">
+            <a:pPr marL="0" indent="0">
               <a:lnSpc>
                 <a:spcPts val="1800"/>
               </a:lnSpc>
@@ -8473,7 +9117,7 @@
           <a:bodyPr wrap="square" lIns="0" tIns="0" rIns="0" bIns="0" rtlCol="0" anchor="ctr"/>
           <a:lstStyle/>
           <a:p>
-            <a:pPr indent="0" marL="0">
+            <a:pPr marL="0" indent="0">
               <a:lnSpc>
                 <a:spcPts val="1500"/>
               </a:lnSpc>
@@ -8515,7 +9159,7 @@
           <a:bodyPr wrap="square" lIns="0" tIns="0" rIns="0" bIns="0" rtlCol="0" anchor="ctr"/>
           <a:lstStyle/>
           <a:p>
-            <a:pPr algn="ctr" indent="0" marL="0">
+            <a:pPr marL="0" indent="0" algn="ctr">
               <a:buNone/>
             </a:pPr>
             <a:r>
@@ -8554,6 +9198,13 @@
           </a:solidFill>
           <a:ln/>
         </p:spPr>
+        <p:txBody>
+          <a:bodyPr/>
+          <a:lstStyle/>
+          <a:p>
+            <a:endParaRPr lang="es-ES"/>
+          </a:p>
+        </p:txBody>
       </p:sp>
       <p:sp>
         <p:nvSpPr>
@@ -8576,7 +9227,7 @@
           <a:bodyPr wrap="square" lIns="0" tIns="0" rIns="0" bIns="0" rtlCol="0" anchor="ctr"/>
           <a:lstStyle/>
           <a:p>
-            <a:pPr indent="0" marL="0">
+            <a:pPr marL="0" indent="0">
               <a:buNone/>
             </a:pPr>
             <a:r>
@@ -8615,7 +9266,7 @@
           <a:bodyPr wrap="square" lIns="0" tIns="0" rIns="0" bIns="0" rtlCol="0" anchor="ctr"/>
           <a:lstStyle/>
           <a:p>
-            <a:pPr indent="0" marL="0">
+            <a:pPr marL="0" indent="0">
               <a:lnSpc>
                 <a:spcPts val="1800"/>
               </a:lnSpc>
@@ -8657,7 +9308,7 @@
           <a:bodyPr wrap="square" lIns="0" tIns="0" rIns="0" bIns="0" rtlCol="0" anchor="ctr"/>
           <a:lstStyle/>
           <a:p>
-            <a:pPr indent="0" marL="0">
+            <a:pPr marL="0" indent="0">
               <a:lnSpc>
                 <a:spcPts val="1500"/>
               </a:lnSpc>
@@ -8699,7 +9350,7 @@
           <a:bodyPr wrap="square" lIns="0" tIns="0" rIns="0" bIns="0" rtlCol="0" anchor="ctr"/>
           <a:lstStyle/>
           <a:p>
-            <a:pPr algn="ctr" indent="0" marL="0">
+            <a:pPr marL="0" indent="0" algn="ctr">
               <a:buNone/>
             </a:pPr>
             <a:r>
@@ -8738,6 +9389,13 @@
           </a:solidFill>
           <a:ln/>
         </p:spPr>
+        <p:txBody>
+          <a:bodyPr/>
+          <a:lstStyle/>
+          <a:p>
+            <a:endParaRPr lang="es-ES"/>
+          </a:p>
+        </p:txBody>
       </p:sp>
       <p:sp>
         <p:nvSpPr>
@@ -8760,7 +9418,7 @@
           <a:bodyPr wrap="square" lIns="0" tIns="0" rIns="0" bIns="0" rtlCol="0" anchor="ctr"/>
           <a:lstStyle/>
           <a:p>
-            <a:pPr indent="0" marL="0">
+            <a:pPr marL="0" indent="0">
               <a:buNone/>
             </a:pPr>
             <a:r>
@@ -8799,7 +9457,7 @@
           <a:bodyPr wrap="square" lIns="0" tIns="0" rIns="0" bIns="0" rtlCol="0" anchor="ctr"/>
           <a:lstStyle/>
           <a:p>
-            <a:pPr indent="0" marL="0">
+            <a:pPr marL="0" indent="0">
               <a:lnSpc>
                 <a:spcPts val="1800"/>
               </a:lnSpc>
@@ -8841,7 +9499,7 @@
           <a:bodyPr wrap="square" lIns="0" tIns="0" rIns="0" bIns="0" rtlCol="0" anchor="ctr"/>
           <a:lstStyle/>
           <a:p>
-            <a:pPr indent="0" marL="0">
+            <a:pPr marL="0" indent="0">
               <a:lnSpc>
                 <a:spcPts val="1500"/>
               </a:lnSpc>
@@ -8883,7 +9541,7 @@
           <a:bodyPr wrap="square" lIns="0" tIns="0" rIns="0" bIns="0" rtlCol="0" anchor="ctr"/>
           <a:lstStyle/>
           <a:p>
-            <a:pPr algn="r" indent="0" marL="0">
+            <a:pPr marL="0" indent="0" algn="r">
               <a:buNone/>
             </a:pPr>
             <a:r>
@@ -8898,6 +9556,63 @@
               <a:t>06</a:t>
             </a:r>
             <a:endParaRPr lang="en-US" sz="1000" dirty="0"/>
+          </a:p>
+        </p:txBody>
+      </p:sp>
+      <p:sp>
+        <p:nvSpPr>
+          <p:cNvPr id="24" name="Text 3">
+            <a:extLst>
+              <a:ext uri="{FF2B5EF4-FFF2-40B4-BE49-F238E27FC236}">
+                <a16:creationId xmlns:a16="http://schemas.microsoft.com/office/drawing/2014/main" id="{9D08E4C5-999B-2DD7-8083-37E3F9A29341}"/>
+              </a:ext>
+            </a:extLst>
+          </p:cNvPr>
+          <p:cNvSpPr/>
+          <p:nvPr/>
+        </p:nvSpPr>
+        <p:spPr>
+          <a:xfrm>
+            <a:off x="9807191" y="6036061"/>
+            <a:ext cx="1788607" cy="457200"/>
+          </a:xfrm>
+          <a:prstGeom prst="rect">
+            <a:avLst/>
+          </a:prstGeom>
+          <a:noFill/>
+          <a:ln/>
+        </p:spPr>
+        <p:txBody>
+          <a:bodyPr wrap="square" lIns="0" tIns="0" rIns="0" bIns="0" rtlCol="0" anchor="ctr"/>
+          <a:lstStyle/>
+          <a:p>
+            <a:pPr marL="0" indent="0">
+              <a:buNone/>
+            </a:pPr>
+            <a:r>
+              <a:rPr lang="en-US" b="1" kern="0" spc="200" dirty="0">
+                <a:solidFill>
+                  <a:srgbClr val="8FD6B8"/>
+                </a:solidFill>
+                <a:latin typeface="Calibri" pitchFamily="34" charset="0"/>
+                <a:ea typeface="Calibri" pitchFamily="34" charset="-122"/>
+                <a:cs typeface="Calibri" pitchFamily="34" charset="-120"/>
+              </a:rPr>
+              <a:t>Link: </a:t>
+            </a:r>
+            <a:r>
+              <a:rPr lang="en-US" b="1" kern="0" spc="200" dirty="0">
+                <a:solidFill>
+                  <a:srgbClr val="8FD6B8"/>
+                </a:solidFill>
+                <a:latin typeface="Calibri" pitchFamily="34" charset="0"/>
+                <a:ea typeface="Calibri" pitchFamily="34" charset="-122"/>
+                <a:cs typeface="Calibri" pitchFamily="34" charset="-120"/>
+                <a:hlinkClick r:id="rId3"/>
+              </a:rPr>
+              <a:t>GitHub</a:t>
+            </a:r>
+            <a:endParaRPr lang="en-US" dirty="0"/>
           </a:p>
         </p:txBody>
       </p:sp>
@@ -8917,6 +9632,7 @@
         <a:solidFill>
           <a:srgbClr val="F7F8F5"/>
         </a:solidFill>
+        <a:effectLst/>
       </p:bgPr>
     </p:bg>
     <p:spTree>
@@ -8954,11 +9670,11 @@
           <a:bodyPr wrap="square" lIns="0" tIns="0" rIns="0" bIns="0" rtlCol="0" anchor="ctr"/>
           <a:lstStyle/>
           <a:p>
-            <a:pPr indent="0" marL="0">
-              <a:buNone/>
-            </a:pPr>
-            <a:r>
-              <a:rPr lang="en-US" sz="1200" b="1" spc="200" kern="0" dirty="0">
+            <a:pPr marL="0" indent="0">
+              <a:buNone/>
+            </a:pPr>
+            <a:r>
+              <a:rPr lang="en-US" sz="1200" b="1" kern="0" spc="200" dirty="0">
                 <a:solidFill>
                   <a:srgbClr val="2F6F5E"/>
                 </a:solidFill>
@@ -8993,7 +9709,7 @@
           <a:bodyPr wrap="square" lIns="0" tIns="0" rIns="0" bIns="0" rtlCol="0" anchor="ctr"/>
           <a:lstStyle/>
           <a:p>
-            <a:pPr indent="0" marL="0">
+            <a:pPr marL="0" indent="0">
               <a:buNone/>
             </a:pPr>
             <a:r>
@@ -9032,7 +9748,7 @@
           <a:bodyPr wrap="square" lIns="0" tIns="0" rIns="0" bIns="0" rtlCol="0" anchor="ctr"/>
           <a:lstStyle/>
           <a:p>
-            <a:pPr indent="0" marL="0">
+            <a:pPr marL="0" indent="0">
               <a:buNone/>
             </a:pPr>
             <a:r>
@@ -9052,14 +9768,14 @@
       </p:sp>
       <p:pic>
         <p:nvPicPr>
-          <p:cNvPr id="5" name="Image 0" descr="D:\Ismael\DESARROLLO\aplicaciones_distribuidas\proyecto-soap-productos\informe\diagrama_arquitectura.png">    </p:cNvPr>
+          <p:cNvPr id="5" name="Image 0" descr="D:\Ismael\DESARROLLO\aplicaciones_distribuidas\proyecto-soap-productos\informe\diagrama_arquitectura.png"/>
           <p:cNvPicPr>
             <a:picLocks noChangeAspect="1"/>
           </p:cNvPicPr>
           <p:nvPr/>
         </p:nvPicPr>
         <p:blipFill>
-          <a:blip r:embed="rId1"/>
+          <a:blip r:embed="rId3"/>
           <a:stretch>
             <a:fillRect/>
           </a:stretch>
@@ -9095,7 +9811,7 @@
           <a:bodyPr wrap="square" lIns="0" tIns="0" rIns="0" bIns="0" rtlCol="0" anchor="ctr"/>
           <a:lstStyle/>
           <a:p>
-            <a:pPr algn="r" indent="0" marL="0">
+            <a:pPr marL="0" indent="0" algn="r">
               <a:buNone/>
             </a:pPr>
             <a:r>
@@ -9110,6 +9826,63 @@
               <a:t>07</a:t>
             </a:r>
             <a:endParaRPr lang="en-US" sz="1000" dirty="0"/>
+          </a:p>
+        </p:txBody>
+      </p:sp>
+      <p:sp>
+        <p:nvSpPr>
+          <p:cNvPr id="7" name="Text 3">
+            <a:extLst>
+              <a:ext uri="{FF2B5EF4-FFF2-40B4-BE49-F238E27FC236}">
+                <a16:creationId xmlns:a16="http://schemas.microsoft.com/office/drawing/2014/main" id="{EA4E783C-9F54-37F1-4C77-6C6022339C46}"/>
+              </a:ext>
+            </a:extLst>
+          </p:cNvPr>
+          <p:cNvSpPr/>
+          <p:nvPr/>
+        </p:nvSpPr>
+        <p:spPr>
+          <a:xfrm>
+            <a:off x="9807191" y="6036061"/>
+            <a:ext cx="1788607" cy="457200"/>
+          </a:xfrm>
+          <a:prstGeom prst="rect">
+            <a:avLst/>
+          </a:prstGeom>
+          <a:noFill/>
+          <a:ln/>
+        </p:spPr>
+        <p:txBody>
+          <a:bodyPr wrap="square" lIns="0" tIns="0" rIns="0" bIns="0" rtlCol="0" anchor="ctr"/>
+          <a:lstStyle/>
+          <a:p>
+            <a:pPr marL="0" indent="0">
+              <a:buNone/>
+            </a:pPr>
+            <a:r>
+              <a:rPr lang="en-US" b="1" kern="0" spc="200" dirty="0">
+                <a:solidFill>
+                  <a:srgbClr val="8FD6B8"/>
+                </a:solidFill>
+                <a:latin typeface="Calibri" pitchFamily="34" charset="0"/>
+                <a:ea typeface="Calibri" pitchFamily="34" charset="-122"/>
+                <a:cs typeface="Calibri" pitchFamily="34" charset="-120"/>
+              </a:rPr>
+              <a:t>Link: </a:t>
+            </a:r>
+            <a:r>
+              <a:rPr lang="en-US" b="1" kern="0" spc="200" dirty="0">
+                <a:solidFill>
+                  <a:srgbClr val="8FD6B8"/>
+                </a:solidFill>
+                <a:latin typeface="Calibri" pitchFamily="34" charset="0"/>
+                <a:ea typeface="Calibri" pitchFamily="34" charset="-122"/>
+                <a:cs typeface="Calibri" pitchFamily="34" charset="-120"/>
+                <a:hlinkClick r:id="rId4"/>
+              </a:rPr>
+              <a:t>GitHub</a:t>
+            </a:r>
+            <a:endParaRPr lang="en-US" dirty="0"/>
           </a:p>
         </p:txBody>
       </p:sp>
@@ -9129,6 +9902,7 @@
         <a:solidFill>
           <a:srgbClr val="F7F8F5"/>
         </a:solidFill>
+        <a:effectLst/>
       </p:bgPr>
     </p:bg>
     <p:spTree>
@@ -9166,11 +9940,11 @@
           <a:bodyPr wrap="square" lIns="0" tIns="0" rIns="0" bIns="0" rtlCol="0" anchor="ctr"/>
           <a:lstStyle/>
           <a:p>
-            <a:pPr indent="0" marL="0">
-              <a:buNone/>
-            </a:pPr>
-            <a:r>
-              <a:rPr lang="en-US" sz="1200" b="1" spc="200" kern="0" dirty="0">
+            <a:pPr marL="0" indent="0">
+              <a:buNone/>
+            </a:pPr>
+            <a:r>
+              <a:rPr lang="en-US" sz="1200" b="1" kern="0" spc="200" dirty="0">
                 <a:solidFill>
                   <a:srgbClr val="2F6F5E"/>
                 </a:solidFill>
@@ -9205,7 +9979,7 @@
           <a:bodyPr wrap="square" lIns="0" tIns="0" rIns="0" bIns="0" rtlCol="0" anchor="ctr"/>
           <a:lstStyle/>
           <a:p>
-            <a:pPr indent="0" marL="0">
+            <a:pPr marL="0" indent="0">
               <a:buNone/>
             </a:pPr>
             <a:r>
@@ -9249,6 +10023,13 @@
             <a:prstDash val="solid"/>
           </a:ln>
         </p:spPr>
+        <p:txBody>
+          <a:bodyPr/>
+          <a:lstStyle/>
+          <a:p>
+            <a:endParaRPr lang="es-ES"/>
+          </a:p>
+        </p:txBody>
       </p:sp>
       <p:sp>
         <p:nvSpPr>
@@ -9269,6 +10050,13 @@
           </a:solidFill>
           <a:ln/>
         </p:spPr>
+        <p:txBody>
+          <a:bodyPr/>
+          <a:lstStyle/>
+          <a:p>
+            <a:endParaRPr lang="es-ES"/>
+          </a:p>
+        </p:txBody>
       </p:sp>
       <p:sp>
         <p:nvSpPr>
@@ -9291,7 +10079,7 @@
           <a:bodyPr wrap="square" lIns="0" tIns="0" rIns="0" bIns="0" rtlCol="0" anchor="ctr"/>
           <a:lstStyle/>
           <a:p>
-            <a:pPr algn="ctr" indent="0" marL="0">
+            <a:pPr marL="0" indent="0" algn="ctr">
               <a:buNone/>
             </a:pPr>
             <a:r>
@@ -9330,7 +10118,7 @@
           <a:bodyPr wrap="square" lIns="0" tIns="0" rIns="0" bIns="0" rtlCol="0" anchor="ctr"/>
           <a:lstStyle/>
           <a:p>
-            <a:pPr indent="0" marL="0">
+            <a:pPr marL="0" indent="0">
               <a:lnSpc>
                 <a:spcPts val="1600"/>
               </a:lnSpc>
@@ -9372,7 +10160,7 @@
           <a:bodyPr wrap="square" lIns="0" tIns="0" rIns="0" bIns="0" rtlCol="0" anchor="ctr"/>
           <a:lstStyle/>
           <a:p>
-            <a:pPr indent="0" marL="0">
+            <a:pPr marL="0" indent="0">
               <a:buNone/>
             </a:pPr>
             <a:r>
@@ -9416,6 +10204,13 @@
             <a:prstDash val="solid"/>
           </a:ln>
         </p:spPr>
+        <p:txBody>
+          <a:bodyPr/>
+          <a:lstStyle/>
+          <a:p>
+            <a:endParaRPr lang="es-ES"/>
+          </a:p>
+        </p:txBody>
       </p:sp>
       <p:sp>
         <p:nvSpPr>
@@ -9436,6 +10231,13 @@
           </a:solidFill>
           <a:ln/>
         </p:spPr>
+        <p:txBody>
+          <a:bodyPr/>
+          <a:lstStyle/>
+          <a:p>
+            <a:endParaRPr lang="es-ES"/>
+          </a:p>
+        </p:txBody>
       </p:sp>
       <p:sp>
         <p:nvSpPr>
@@ -9458,7 +10260,7 @@
           <a:bodyPr wrap="square" lIns="0" tIns="0" rIns="0" bIns="0" rtlCol="0" anchor="ctr"/>
           <a:lstStyle/>
           <a:p>
-            <a:pPr algn="ctr" indent="0" marL="0">
+            <a:pPr marL="0" indent="0" algn="ctr">
               <a:buNone/>
             </a:pPr>
             <a:r>
@@ -9497,7 +10299,7 @@
           <a:bodyPr wrap="square" lIns="0" tIns="0" rIns="0" bIns="0" rtlCol="0" anchor="ctr"/>
           <a:lstStyle/>
           <a:p>
-            <a:pPr indent="0" marL="0">
+            <a:pPr marL="0" indent="0">
               <a:lnSpc>
                 <a:spcPts val="1600"/>
               </a:lnSpc>
@@ -9539,7 +10341,7 @@
           <a:bodyPr wrap="square" lIns="0" tIns="0" rIns="0" bIns="0" rtlCol="0" anchor="ctr"/>
           <a:lstStyle/>
           <a:p>
-            <a:pPr indent="0" marL="0">
+            <a:pPr marL="0" indent="0">
               <a:buNone/>
             </a:pPr>
             <a:r>
@@ -9583,6 +10385,13 @@
             <a:prstDash val="solid"/>
           </a:ln>
         </p:spPr>
+        <p:txBody>
+          <a:bodyPr/>
+          <a:lstStyle/>
+          <a:p>
+            <a:endParaRPr lang="es-ES"/>
+          </a:p>
+        </p:txBody>
       </p:sp>
       <p:sp>
         <p:nvSpPr>
@@ -9603,6 +10412,13 @@
           </a:solidFill>
           <a:ln/>
         </p:spPr>
+        <p:txBody>
+          <a:bodyPr/>
+          <a:lstStyle/>
+          <a:p>
+            <a:endParaRPr lang="es-ES"/>
+          </a:p>
+        </p:txBody>
       </p:sp>
       <p:sp>
         <p:nvSpPr>
@@ -9625,7 +10441,7 @@
           <a:bodyPr wrap="square" lIns="0" tIns="0" rIns="0" bIns="0" rtlCol="0" anchor="ctr"/>
           <a:lstStyle/>
           <a:p>
-            <a:pPr algn="ctr" indent="0" marL="0">
+            <a:pPr marL="0" indent="0" algn="ctr">
               <a:buNone/>
             </a:pPr>
             <a:r>
@@ -9664,7 +10480,7 @@
           <a:bodyPr wrap="square" lIns="0" tIns="0" rIns="0" bIns="0" rtlCol="0" anchor="ctr"/>
           <a:lstStyle/>
           <a:p>
-            <a:pPr indent="0" marL="0">
+            <a:pPr marL="0" indent="0">
               <a:lnSpc>
                 <a:spcPts val="1600"/>
               </a:lnSpc>
@@ -9706,7 +10522,7 @@
           <a:bodyPr wrap="square" lIns="0" tIns="0" rIns="0" bIns="0" rtlCol="0" anchor="ctr"/>
           <a:lstStyle/>
           <a:p>
-            <a:pPr indent="0" marL="0">
+            <a:pPr marL="0" indent="0">
               <a:buNone/>
             </a:pPr>
             <a:r>
@@ -9750,6 +10566,13 @@
             <a:prstDash val="solid"/>
           </a:ln>
         </p:spPr>
+        <p:txBody>
+          <a:bodyPr/>
+          <a:lstStyle/>
+          <a:p>
+            <a:endParaRPr lang="es-ES"/>
+          </a:p>
+        </p:txBody>
       </p:sp>
       <p:sp>
         <p:nvSpPr>
@@ -9770,6 +10593,13 @@
           </a:solidFill>
           <a:ln/>
         </p:spPr>
+        <p:txBody>
+          <a:bodyPr/>
+          <a:lstStyle/>
+          <a:p>
+            <a:endParaRPr lang="es-ES"/>
+          </a:p>
+        </p:txBody>
       </p:sp>
       <p:sp>
         <p:nvSpPr>
@@ -9792,7 +10622,7 @@
           <a:bodyPr wrap="square" lIns="0" tIns="0" rIns="0" bIns="0" rtlCol="0" anchor="ctr"/>
           <a:lstStyle/>
           <a:p>
-            <a:pPr algn="ctr" indent="0" marL="0">
+            <a:pPr marL="0" indent="0" algn="ctr">
               <a:buNone/>
             </a:pPr>
             <a:r>
@@ -9831,7 +10661,7 @@
           <a:bodyPr wrap="square" lIns="0" tIns="0" rIns="0" bIns="0" rtlCol="0" anchor="ctr"/>
           <a:lstStyle/>
           <a:p>
-            <a:pPr indent="0" marL="0">
+            <a:pPr marL="0" indent="0">
               <a:lnSpc>
                 <a:spcPts val="1600"/>
               </a:lnSpc>
@@ -9873,7 +10703,7 @@
           <a:bodyPr wrap="square" lIns="0" tIns="0" rIns="0" bIns="0" rtlCol="0" anchor="ctr"/>
           <a:lstStyle/>
           <a:p>
-            <a:pPr indent="0" marL="0">
+            <a:pPr marL="0" indent="0">
               <a:buNone/>
             </a:pPr>
             <a:r>
@@ -9917,6 +10747,13 @@
             <a:prstDash val="solid"/>
           </a:ln>
         </p:spPr>
+        <p:txBody>
+          <a:bodyPr/>
+          <a:lstStyle/>
+          <a:p>
+            <a:endParaRPr lang="es-ES"/>
+          </a:p>
+        </p:txBody>
       </p:sp>
       <p:sp>
         <p:nvSpPr>
@@ -9937,6 +10774,13 @@
           </a:solidFill>
           <a:ln/>
         </p:spPr>
+        <p:txBody>
+          <a:bodyPr/>
+          <a:lstStyle/>
+          <a:p>
+            <a:endParaRPr lang="es-ES"/>
+          </a:p>
+        </p:txBody>
       </p:sp>
       <p:sp>
         <p:nvSpPr>
@@ -9959,7 +10803,7 @@
           <a:bodyPr wrap="square" lIns="0" tIns="0" rIns="0" bIns="0" rtlCol="0" anchor="ctr"/>
           <a:lstStyle/>
           <a:p>
-            <a:pPr algn="ctr" indent="0" marL="0">
+            <a:pPr marL="0" indent="0" algn="ctr">
               <a:buNone/>
             </a:pPr>
             <a:r>
@@ -9998,7 +10842,7 @@
           <a:bodyPr wrap="square" lIns="0" tIns="0" rIns="0" bIns="0" rtlCol="0" anchor="ctr"/>
           <a:lstStyle/>
           <a:p>
-            <a:pPr indent="0" marL="0">
+            <a:pPr marL="0" indent="0">
               <a:lnSpc>
                 <a:spcPts val="1600"/>
               </a:lnSpc>
@@ -10040,7 +10884,7 @@
           <a:bodyPr wrap="square" lIns="0" tIns="0" rIns="0" bIns="0" rtlCol="0" anchor="ctr"/>
           <a:lstStyle/>
           <a:p>
-            <a:pPr indent="0" marL="0">
+            <a:pPr marL="0" indent="0">
               <a:buNone/>
             </a:pPr>
             <a:r>
@@ -10084,6 +10928,13 @@
             <a:prstDash val="solid"/>
           </a:ln>
         </p:spPr>
+        <p:txBody>
+          <a:bodyPr/>
+          <a:lstStyle/>
+          <a:p>
+            <a:endParaRPr lang="es-ES"/>
+          </a:p>
+        </p:txBody>
       </p:sp>
       <p:sp>
         <p:nvSpPr>
@@ -10104,6 +10955,13 @@
           </a:solidFill>
           <a:ln/>
         </p:spPr>
+        <p:txBody>
+          <a:bodyPr/>
+          <a:lstStyle/>
+          <a:p>
+            <a:endParaRPr lang="es-ES"/>
+          </a:p>
+        </p:txBody>
       </p:sp>
       <p:sp>
         <p:nvSpPr>
@@ -10126,7 +10984,7 @@
           <a:bodyPr wrap="square" lIns="0" tIns="0" rIns="0" bIns="0" rtlCol="0" anchor="ctr"/>
           <a:lstStyle/>
           <a:p>
-            <a:pPr algn="ctr" indent="0" marL="0">
+            <a:pPr marL="0" indent="0" algn="ctr">
               <a:buNone/>
             </a:pPr>
             <a:r>
@@ -10165,7 +11023,7 @@
           <a:bodyPr wrap="square" lIns="0" tIns="0" rIns="0" bIns="0" rtlCol="0" anchor="ctr"/>
           <a:lstStyle/>
           <a:p>
-            <a:pPr indent="0" marL="0">
+            <a:pPr marL="0" indent="0">
               <a:lnSpc>
                 <a:spcPts val="1600"/>
               </a:lnSpc>
@@ -10207,7 +11065,7 @@
           <a:bodyPr wrap="square" lIns="0" tIns="0" rIns="0" bIns="0" rtlCol="0" anchor="ctr"/>
           <a:lstStyle/>
           <a:p>
-            <a:pPr indent="0" marL="0">
+            <a:pPr marL="0" indent="0">
               <a:buNone/>
             </a:pPr>
             <a:r>
@@ -10246,7 +11104,7 @@
           <a:bodyPr wrap="square" lIns="0" tIns="0" rIns="0" bIns="0" rtlCol="0" anchor="ctr"/>
           <a:lstStyle/>
           <a:p>
-            <a:pPr algn="r" indent="0" marL="0">
+            <a:pPr marL="0" indent="0" algn="r">
               <a:buNone/>
             </a:pPr>
             <a:r>
@@ -10261,6 +11119,63 @@
               <a:t>08</a:t>
             </a:r>
             <a:endParaRPr lang="en-US" sz="1000" dirty="0"/>
+          </a:p>
+        </p:txBody>
+      </p:sp>
+      <p:sp>
+        <p:nvSpPr>
+          <p:cNvPr id="35" name="Text 3">
+            <a:extLst>
+              <a:ext uri="{FF2B5EF4-FFF2-40B4-BE49-F238E27FC236}">
+                <a16:creationId xmlns:a16="http://schemas.microsoft.com/office/drawing/2014/main" id="{9B89588D-948D-AFB4-67F2-12EF406D835C}"/>
+              </a:ext>
+            </a:extLst>
+          </p:cNvPr>
+          <p:cNvSpPr/>
+          <p:nvPr/>
+        </p:nvSpPr>
+        <p:spPr>
+          <a:xfrm>
+            <a:off x="9807191" y="6036061"/>
+            <a:ext cx="1788607" cy="457200"/>
+          </a:xfrm>
+          <a:prstGeom prst="rect">
+            <a:avLst/>
+          </a:prstGeom>
+          <a:noFill/>
+          <a:ln/>
+        </p:spPr>
+        <p:txBody>
+          <a:bodyPr wrap="square" lIns="0" tIns="0" rIns="0" bIns="0" rtlCol="0" anchor="ctr"/>
+          <a:lstStyle/>
+          <a:p>
+            <a:pPr marL="0" indent="0">
+              <a:buNone/>
+            </a:pPr>
+            <a:r>
+              <a:rPr lang="en-US" b="1" kern="0" spc="200" dirty="0">
+                <a:solidFill>
+                  <a:srgbClr val="8FD6B8"/>
+                </a:solidFill>
+                <a:latin typeface="Calibri" pitchFamily="34" charset="0"/>
+                <a:ea typeface="Calibri" pitchFamily="34" charset="-122"/>
+                <a:cs typeface="Calibri" pitchFamily="34" charset="-120"/>
+              </a:rPr>
+              <a:t>Link: </a:t>
+            </a:r>
+            <a:r>
+              <a:rPr lang="en-US" b="1" kern="0" spc="200" dirty="0">
+                <a:solidFill>
+                  <a:srgbClr val="8FD6B8"/>
+                </a:solidFill>
+                <a:latin typeface="Calibri" pitchFamily="34" charset="0"/>
+                <a:ea typeface="Calibri" pitchFamily="34" charset="-122"/>
+                <a:cs typeface="Calibri" pitchFamily="34" charset="-120"/>
+                <a:hlinkClick r:id="rId3"/>
+              </a:rPr>
+              <a:t>GitHub</a:t>
+            </a:r>
+            <a:endParaRPr lang="en-US" dirty="0"/>
           </a:p>
         </p:txBody>
       </p:sp>
@@ -10280,6 +11195,7 @@
         <a:solidFill>
           <a:srgbClr val="16211D"/>
         </a:solidFill>
+        <a:effectLst/>
       </p:bgPr>
     </p:bg>
     <p:spTree>
@@ -10317,11 +11233,11 @@
           <a:bodyPr wrap="square" lIns="0" tIns="0" rIns="0" bIns="0" rtlCol="0" anchor="ctr"/>
           <a:lstStyle/>
           <a:p>
-            <a:pPr indent="0" marL="0">
-              <a:buNone/>
-            </a:pPr>
-            <a:r>
-              <a:rPr lang="en-US" sz="1200" b="1" spc="200" kern="0" dirty="0">
+            <a:pPr marL="0" indent="0">
+              <a:buNone/>
+            </a:pPr>
+            <a:r>
+              <a:rPr lang="en-US" sz="1200" b="1" kern="0" spc="200" dirty="0">
                 <a:solidFill>
                   <a:srgbClr val="8FD6B8"/>
                 </a:solidFill>
@@ -10356,7 +11272,7 @@
           <a:bodyPr wrap="square" lIns="0" tIns="0" rIns="0" bIns="0" rtlCol="0" anchor="ctr"/>
           <a:lstStyle/>
           <a:p>
-            <a:pPr indent="0" marL="0">
+            <a:pPr marL="0" indent="0">
               <a:lnSpc>
                 <a:spcPts val="3400"/>
               </a:lnSpc>
@@ -10376,7 +11292,7 @@
             <a:endParaRPr lang="en-US" sz="3000" dirty="0"/>
           </a:p>
           <a:p>
-            <a:pPr indent="0" marL="0">
+            <a:pPr marL="0" indent="0">
               <a:lnSpc>
                 <a:spcPts val="3400"/>
               </a:lnSpc>
@@ -10416,6 +11332,13 @@
           </a:solidFill>
           <a:ln/>
         </p:spPr>
+        <p:txBody>
+          <a:bodyPr/>
+          <a:lstStyle/>
+          <a:p>
+            <a:endParaRPr lang="es-ES"/>
+          </a:p>
+        </p:txBody>
       </p:sp>
       <p:sp>
         <p:nvSpPr>
@@ -10438,7 +11361,7 @@
           <a:bodyPr wrap="square" lIns="0" tIns="0" rIns="0" bIns="0" rtlCol="0" anchor="ctr"/>
           <a:lstStyle/>
           <a:p>
-            <a:pPr indent="0" marL="0">
+            <a:pPr marL="0" indent="0">
               <a:buNone/>
             </a:pPr>
             <a:r>
@@ -10475,6 +11398,13 @@
           </a:solidFill>
           <a:ln/>
         </p:spPr>
+        <p:txBody>
+          <a:bodyPr/>
+          <a:lstStyle/>
+          <a:p>
+            <a:endParaRPr lang="es-ES"/>
+          </a:p>
+        </p:txBody>
       </p:sp>
       <p:sp>
         <p:nvSpPr>
@@ -10497,7 +11427,7 @@
           <a:bodyPr wrap="square" lIns="0" tIns="0" rIns="0" bIns="0" rtlCol="0" anchor="ctr"/>
           <a:lstStyle/>
           <a:p>
-            <a:pPr indent="0" marL="0">
+            <a:pPr marL="0" indent="0">
               <a:buNone/>
             </a:pPr>
             <a:r>
@@ -10534,6 +11464,13 @@
           </a:solidFill>
           <a:ln/>
         </p:spPr>
+        <p:txBody>
+          <a:bodyPr/>
+          <a:lstStyle/>
+          <a:p>
+            <a:endParaRPr lang="es-ES"/>
+          </a:p>
+        </p:txBody>
       </p:sp>
       <p:sp>
         <p:nvSpPr>
@@ -10556,7 +11493,7 @@
           <a:bodyPr wrap="square" lIns="0" tIns="0" rIns="0" bIns="0" rtlCol="0" anchor="ctr"/>
           <a:lstStyle/>
           <a:p>
-            <a:pPr indent="0" marL="0">
+            <a:pPr marL="0" indent="0">
               <a:buNone/>
             </a:pPr>
             <a:r>
@@ -10593,6 +11530,13 @@
           </a:solidFill>
           <a:ln/>
         </p:spPr>
+        <p:txBody>
+          <a:bodyPr/>
+          <a:lstStyle/>
+          <a:p>
+            <a:endParaRPr lang="es-ES"/>
+          </a:p>
+        </p:txBody>
       </p:sp>
       <p:sp>
         <p:nvSpPr>
@@ -10615,7 +11559,7 @@
           <a:bodyPr wrap="square" lIns="0" tIns="0" rIns="0" bIns="0" rtlCol="0" anchor="ctr"/>
           <a:lstStyle/>
           <a:p>
-            <a:pPr indent="0" marL="0">
+            <a:pPr marL="0" indent="0">
               <a:buNone/>
             </a:pPr>
             <a:r>
@@ -10652,6 +11596,13 @@
           </a:solidFill>
           <a:ln/>
         </p:spPr>
+        <p:txBody>
+          <a:bodyPr/>
+          <a:lstStyle/>
+          <a:p>
+            <a:endParaRPr lang="es-ES"/>
+          </a:p>
+        </p:txBody>
       </p:sp>
       <p:sp>
         <p:nvSpPr>
@@ -10674,7 +11625,7 @@
           <a:bodyPr wrap="square" lIns="0" tIns="0" rIns="0" bIns="0" rtlCol="0" anchor="ctr"/>
           <a:lstStyle/>
           <a:p>
-            <a:pPr indent="0" marL="0">
+            <a:pPr marL="0" indent="0">
               <a:buNone/>
             </a:pPr>
             <a:r>
@@ -10718,6 +11669,13 @@
             <a:prstDash val="solid"/>
           </a:ln>
         </p:spPr>
+        <p:txBody>
+          <a:bodyPr/>
+          <a:lstStyle/>
+          <a:p>
+            <a:endParaRPr lang="es-ES"/>
+          </a:p>
+        </p:txBody>
       </p:sp>
       <p:sp>
         <p:nvSpPr>
@@ -10740,11 +11698,11 @@
           <a:bodyPr wrap="square" lIns="0" tIns="0" rIns="0" bIns="0" rtlCol="0" anchor="ctr"/>
           <a:lstStyle/>
           <a:p>
-            <a:pPr indent="0" marL="0">
-              <a:buNone/>
-            </a:pPr>
-            <a:r>
-              <a:rPr lang="en-US" sz="1100" b="1" spc="100" kern="0" dirty="0">
+            <a:pPr marL="0" indent="0">
+              <a:buNone/>
+            </a:pPr>
+            <a:r>
+              <a:rPr lang="en-US" sz="1100" b="1" kern="0" spc="100" dirty="0">
                 <a:solidFill>
                   <a:srgbClr val="9AA69C"/>
                 </a:solidFill>
@@ -10779,7 +11737,7 @@
           <a:bodyPr wrap="square" lIns="0" tIns="0" rIns="0" bIns="0" rtlCol="0" anchor="ctr"/>
           <a:lstStyle/>
           <a:p>
-            <a:pPr indent="0" marL="0">
+            <a:pPr marL="0" indent="0">
               <a:lnSpc>
                 <a:spcPts val="1900"/>
               </a:lnSpc>
@@ -10799,7 +11757,7 @@
             <a:endParaRPr lang="en-US" sz="1300" dirty="0"/>
           </a:p>
           <a:p>
-            <a:pPr indent="0" marL="0">
+            <a:pPr marL="0" indent="0">
               <a:lnSpc>
                 <a:spcPts val="1900"/>
               </a:lnSpc>
@@ -10819,7 +11777,7 @@
             <a:endParaRPr lang="en-US" sz="1300" dirty="0"/>
           </a:p>
           <a:p>
-            <a:pPr indent="0" marL="0">
+            <a:pPr marL="0" indent="0">
               <a:lnSpc>
                 <a:spcPts val="1900"/>
               </a:lnSpc>
@@ -10839,7 +11797,7 @@
             <a:endParaRPr lang="en-US" sz="1300" dirty="0"/>
           </a:p>
           <a:p>
-            <a:pPr indent="0" marL="0">
+            <a:pPr marL="0" indent="0">
               <a:lnSpc>
                 <a:spcPts val="1900"/>
               </a:lnSpc>
@@ -10859,7 +11817,7 @@
             <a:endParaRPr lang="en-US" sz="1300" dirty="0"/>
           </a:p>
           <a:p>
-            <a:pPr indent="0" marL="0">
+            <a:pPr marL="0" indent="0">
               <a:lnSpc>
                 <a:spcPts val="1900"/>
               </a:lnSpc>
@@ -10901,7 +11859,7 @@
           <a:bodyPr wrap="square" lIns="0" tIns="0" rIns="0" bIns="0" rtlCol="0" anchor="ctr"/>
           <a:lstStyle/>
           <a:p>
-            <a:pPr algn="r" indent="0" marL="0">
+            <a:pPr marL="0" indent="0" algn="r">
               <a:buNone/>
             </a:pPr>
             <a:r>
@@ -10916,6 +11874,63 @@
               <a:t>09</a:t>
             </a:r>
             <a:endParaRPr lang="en-US" sz="1000" dirty="0"/>
+          </a:p>
+        </p:txBody>
+      </p:sp>
+      <p:sp>
+        <p:nvSpPr>
+          <p:cNvPr id="18" name="Text 3">
+            <a:extLst>
+              <a:ext uri="{FF2B5EF4-FFF2-40B4-BE49-F238E27FC236}">
+                <a16:creationId xmlns:a16="http://schemas.microsoft.com/office/drawing/2014/main" id="{2AF89016-88E2-9EC7-F86C-DBE59339177A}"/>
+              </a:ext>
+            </a:extLst>
+          </p:cNvPr>
+          <p:cNvSpPr/>
+          <p:nvPr/>
+        </p:nvSpPr>
+        <p:spPr>
+          <a:xfrm>
+            <a:off x="9807191" y="6036061"/>
+            <a:ext cx="1788607" cy="457200"/>
+          </a:xfrm>
+          <a:prstGeom prst="rect">
+            <a:avLst/>
+          </a:prstGeom>
+          <a:noFill/>
+          <a:ln/>
+        </p:spPr>
+        <p:txBody>
+          <a:bodyPr wrap="square" lIns="0" tIns="0" rIns="0" bIns="0" rtlCol="0" anchor="ctr"/>
+          <a:lstStyle/>
+          <a:p>
+            <a:pPr marL="0" indent="0">
+              <a:buNone/>
+            </a:pPr>
+            <a:r>
+              <a:rPr lang="en-US" b="1" kern="0" spc="200" dirty="0">
+                <a:solidFill>
+                  <a:srgbClr val="8FD6B8"/>
+                </a:solidFill>
+                <a:latin typeface="Calibri" pitchFamily="34" charset="0"/>
+                <a:ea typeface="Calibri" pitchFamily="34" charset="-122"/>
+                <a:cs typeface="Calibri" pitchFamily="34" charset="-120"/>
+              </a:rPr>
+              <a:t>Link: </a:t>
+            </a:r>
+            <a:r>
+              <a:rPr lang="en-US" b="1" kern="0" spc="200" dirty="0">
+                <a:solidFill>
+                  <a:srgbClr val="8FD6B8"/>
+                </a:solidFill>
+                <a:latin typeface="Calibri" pitchFamily="34" charset="0"/>
+                <a:ea typeface="Calibri" pitchFamily="34" charset="-122"/>
+                <a:cs typeface="Calibri" pitchFamily="34" charset="-120"/>
+                <a:hlinkClick r:id="rId3"/>
+              </a:rPr>
+              <a:t>GitHub</a:t>
+            </a:r>
+            <a:endParaRPr lang="en-US" dirty="0"/>
           </a:p>
         </p:txBody>
       </p:sp>
@@ -11220,4 +12235,319 @@
     </a:ext>
   </a:extLst>
 </a:theme>
+</file>
+
+<file path=ppt/theme/theme2.xml><?xml version="1.0" encoding="utf-8"?>
+<a:theme xmlns:a="http://schemas.openxmlformats.org/drawingml/2006/main" name="Tema de Office">
+  <a:themeElements>
+    <a:clrScheme name="Office">
+      <a:dk1>
+        <a:sysClr val="windowText" lastClr="000000"/>
+      </a:dk1>
+      <a:lt1>
+        <a:sysClr val="window" lastClr="FFFFFF"/>
+      </a:lt1>
+      <a:dk2>
+        <a:srgbClr val="0E2841"/>
+      </a:dk2>
+      <a:lt2>
+        <a:srgbClr val="E8E8E8"/>
+      </a:lt2>
+      <a:accent1>
+        <a:srgbClr val="156082"/>
+      </a:accent1>
+      <a:accent2>
+        <a:srgbClr val="E97132"/>
+      </a:accent2>
+      <a:accent3>
+        <a:srgbClr val="196B24"/>
+      </a:accent3>
+      <a:accent4>
+        <a:srgbClr val="0F9ED5"/>
+      </a:accent4>
+      <a:accent5>
+        <a:srgbClr val="A02B93"/>
+      </a:accent5>
+      <a:accent6>
+        <a:srgbClr val="4EA72E"/>
+      </a:accent6>
+      <a:hlink>
+        <a:srgbClr val="467886"/>
+      </a:hlink>
+      <a:folHlink>
+        <a:srgbClr val="96607D"/>
+      </a:folHlink>
+    </a:clrScheme>
+    <a:fontScheme name="Office">
+      <a:majorFont>
+        <a:latin typeface="Aptos Display" panose="02110004020202020204"/>
+        <a:ea typeface=""/>
+        <a:cs typeface=""/>
+        <a:font script="Jpan" typeface="游ゴシック Light"/>
+        <a:font script="Hang" typeface="맑은 고딕"/>
+        <a:font script="Hans" typeface="等线 Light"/>
+        <a:font script="Hant" typeface="新細明體"/>
+        <a:font script="Arab" typeface="Times New Roman"/>
+        <a:font script="Hebr" typeface="Times New Roman"/>
+        <a:font script="Thai" typeface="Angsana New"/>
+        <a:font script="Ethi" typeface="Nyala"/>
+        <a:font script="Beng" typeface="Vrinda"/>
+        <a:font script="Gujr" typeface="Shruti"/>
+        <a:font script="Khmr" typeface="MoolBoran"/>
+        <a:font script="Knda" typeface="Tunga"/>
+        <a:font script="Guru" typeface="Raavi"/>
+        <a:font script="Cans" typeface="Euphemia"/>
+        <a:font script="Cher" typeface="Plantagenet Cherokee"/>
+        <a:font script="Yiii" typeface="Microsoft Yi Baiti"/>
+        <a:font script="Tibt" typeface="Microsoft Himalaya"/>
+        <a:font script="Thaa" typeface="MV Boli"/>
+        <a:font script="Deva" typeface="Mangal"/>
+        <a:font script="Telu" typeface="Gautami"/>
+        <a:font script="Taml" typeface="Latha"/>
+        <a:font script="Syrc" typeface="Estrangelo Edessa"/>
+        <a:font script="Orya" typeface="Kalinga"/>
+        <a:font script="Mlym" typeface="Kartika"/>
+        <a:font script="Laoo" typeface="DokChampa"/>
+        <a:font script="Sinh" typeface="Iskoola Pota"/>
+        <a:font script="Mong" typeface="Mongolian Baiti"/>
+        <a:font script="Viet" typeface="Times New Roman"/>
+        <a:font script="Uigh" typeface="Microsoft Uighur"/>
+        <a:font script="Geor" typeface="Sylfaen"/>
+        <a:font script="Armn" typeface="Arial"/>
+        <a:font script="Bugi" typeface="Leelawadee UI"/>
+        <a:font script="Bopo" typeface="Microsoft JhengHei"/>
+        <a:font script="Java" typeface="Javanese Text"/>
+        <a:font script="Lisu" typeface="Segoe UI"/>
+        <a:font script="Mymr" typeface="Myanmar Text"/>
+        <a:font script="Nkoo" typeface="Ebrima"/>
+        <a:font script="Olck" typeface="Nirmala UI"/>
+        <a:font script="Osma" typeface="Ebrima"/>
+        <a:font script="Phag" typeface="Phagspa"/>
+        <a:font script="Syrn" typeface="Estrangelo Edessa"/>
+        <a:font script="Syrj" typeface="Estrangelo Edessa"/>
+        <a:font script="Syre" typeface="Estrangelo Edessa"/>
+        <a:font script="Sora" typeface="Nirmala UI"/>
+        <a:font script="Tale" typeface="Microsoft Tai Le"/>
+        <a:font script="Talu" typeface="Microsoft New Tai Lue"/>
+        <a:font script="Tfng" typeface="Ebrima"/>
+      </a:majorFont>
+      <a:minorFont>
+        <a:latin typeface="Aptos" panose="02110004020202020204"/>
+        <a:ea typeface=""/>
+        <a:cs typeface=""/>
+        <a:font script="Jpan" typeface="游ゴシック"/>
+        <a:font script="Hang" typeface="맑은 고딕"/>
+        <a:font script="Hans" typeface="等线"/>
+        <a:font script="Hant" typeface="新細明體"/>
+        <a:font script="Arab" typeface="Arial"/>
+        <a:font script="Hebr" typeface="Arial"/>
+        <a:font script="Thai" typeface="Cordia New"/>
+        <a:font script="Ethi" typeface="Nyala"/>
+        <a:font script="Beng" typeface="Vrinda"/>
+        <a:font script="Gujr" typeface="Shruti"/>
+        <a:font script="Khmr" typeface="DaunPenh"/>
+        <a:font script="Knda" typeface="Tunga"/>
+        <a:font script="Guru" typeface="Raavi"/>
+        <a:font script="Cans" typeface="Euphemia"/>
+        <a:font script="Cher" typeface="Plantagenet Cherokee"/>
+        <a:font script="Yiii" typeface="Microsoft Yi Baiti"/>
+        <a:font script="Tibt" typeface="Microsoft Himalaya"/>
+        <a:font script="Thaa" typeface="MV Boli"/>
+        <a:font script="Deva" typeface="Mangal"/>
+        <a:font script="Telu" typeface="Gautami"/>
+        <a:font script="Taml" typeface="Latha"/>
+        <a:font script="Syrc" typeface="Estrangelo Edessa"/>
+        <a:font script="Orya" typeface="Kalinga"/>
+        <a:font script="Mlym" typeface="Kartika"/>
+        <a:font script="Laoo" typeface="DokChampa"/>
+        <a:font script="Sinh" typeface="Iskoola Pota"/>
+        <a:font script="Mong" typeface="Mongolian Baiti"/>
+        <a:font script="Viet" typeface="Arial"/>
+        <a:font script="Uigh" typeface="Microsoft Uighur"/>
+        <a:font script="Geor" typeface="Sylfaen"/>
+        <a:font script="Armn" typeface="Arial"/>
+        <a:font script="Bugi" typeface="Leelawadee UI"/>
+        <a:font script="Bopo" typeface="Microsoft JhengHei"/>
+        <a:font script="Java" typeface="Javanese Text"/>
+        <a:font script="Lisu" typeface="Segoe UI"/>
+        <a:font script="Mymr" typeface="Myanmar Text"/>
+        <a:font script="Nkoo" typeface="Ebrima"/>
+        <a:font script="Olck" typeface="Nirmala UI"/>
+        <a:font script="Osma" typeface="Ebrima"/>
+        <a:font script="Phag" typeface="Phagspa"/>
+        <a:font script="Syrn" typeface="Estrangelo Edessa"/>
+        <a:font script="Syrj" typeface="Estrangelo Edessa"/>
+        <a:font script="Syre" typeface="Estrangelo Edessa"/>
+        <a:font script="Sora" typeface="Nirmala UI"/>
+        <a:font script="Tale" typeface="Microsoft Tai Le"/>
+        <a:font script="Talu" typeface="Microsoft New Tai Lue"/>
+        <a:font script="Tfng" typeface="Ebrima"/>
+      </a:minorFont>
+    </a:fontScheme>
+    <a:fmtScheme name="Office">
+      <a:fillStyleLst>
+        <a:solidFill>
+          <a:schemeClr val="phClr"/>
+        </a:solidFill>
+        <a:gradFill rotWithShape="1">
+          <a:gsLst>
+            <a:gs pos="0">
+              <a:schemeClr val="phClr">
+                <a:lumMod val="110000"/>
+                <a:satMod val="105000"/>
+                <a:tint val="67000"/>
+              </a:schemeClr>
+            </a:gs>
+            <a:gs pos="50000">
+              <a:schemeClr val="phClr">
+                <a:lumMod val="105000"/>
+                <a:satMod val="103000"/>
+                <a:tint val="73000"/>
+              </a:schemeClr>
+            </a:gs>
+            <a:gs pos="100000">
+              <a:schemeClr val="phClr">
+                <a:lumMod val="105000"/>
+                <a:satMod val="109000"/>
+                <a:tint val="81000"/>
+              </a:schemeClr>
+            </a:gs>
+          </a:gsLst>
+          <a:lin ang="5400000" scaled="0"/>
+        </a:gradFill>
+        <a:gradFill rotWithShape="1">
+          <a:gsLst>
+            <a:gs pos="0">
+              <a:schemeClr val="phClr">
+                <a:satMod val="103000"/>
+                <a:lumMod val="102000"/>
+                <a:tint val="94000"/>
+              </a:schemeClr>
+            </a:gs>
+            <a:gs pos="50000">
+              <a:schemeClr val="phClr">
+                <a:satMod val="110000"/>
+                <a:lumMod val="100000"/>
+                <a:shade val="100000"/>
+              </a:schemeClr>
+            </a:gs>
+            <a:gs pos="100000">
+              <a:schemeClr val="phClr">
+                <a:lumMod val="99000"/>
+                <a:satMod val="120000"/>
+                <a:shade val="78000"/>
+              </a:schemeClr>
+            </a:gs>
+          </a:gsLst>
+          <a:lin ang="5400000" scaled="0"/>
+        </a:gradFill>
+      </a:fillStyleLst>
+      <a:lnStyleLst>
+        <a:ln w="12700" cap="flat" cmpd="sng" algn="ctr">
+          <a:solidFill>
+            <a:schemeClr val="phClr"/>
+          </a:solidFill>
+          <a:prstDash val="solid"/>
+          <a:miter lim="800000"/>
+        </a:ln>
+        <a:ln w="19050" cap="flat" cmpd="sng" algn="ctr">
+          <a:solidFill>
+            <a:schemeClr val="phClr"/>
+          </a:solidFill>
+          <a:prstDash val="solid"/>
+          <a:miter lim="800000"/>
+        </a:ln>
+        <a:ln w="25400" cap="flat" cmpd="sng" algn="ctr">
+          <a:solidFill>
+            <a:schemeClr val="phClr"/>
+          </a:solidFill>
+          <a:prstDash val="solid"/>
+          <a:miter lim="800000"/>
+        </a:ln>
+      </a:lnStyleLst>
+      <a:effectStyleLst>
+        <a:effectStyle>
+          <a:effectLst/>
+        </a:effectStyle>
+        <a:effectStyle>
+          <a:effectLst/>
+        </a:effectStyle>
+        <a:effectStyle>
+          <a:effectLst>
+            <a:outerShdw blurRad="57150" dist="19050" dir="5400000" algn="ctr" rotWithShape="0">
+              <a:srgbClr val="000000">
+                <a:alpha val="63000"/>
+              </a:srgbClr>
+            </a:outerShdw>
+          </a:effectLst>
+        </a:effectStyle>
+      </a:effectStyleLst>
+      <a:bgFillStyleLst>
+        <a:solidFill>
+          <a:schemeClr val="phClr"/>
+        </a:solidFill>
+        <a:solidFill>
+          <a:schemeClr val="phClr">
+            <a:tint val="95000"/>
+            <a:satMod val="170000"/>
+          </a:schemeClr>
+        </a:solidFill>
+        <a:gradFill rotWithShape="1">
+          <a:gsLst>
+            <a:gs pos="0">
+              <a:schemeClr val="phClr">
+                <a:tint val="93000"/>
+                <a:satMod val="150000"/>
+                <a:shade val="98000"/>
+                <a:lumMod val="102000"/>
+              </a:schemeClr>
+            </a:gs>
+            <a:gs pos="50000">
+              <a:schemeClr val="phClr">
+                <a:tint val="98000"/>
+                <a:satMod val="130000"/>
+                <a:shade val="90000"/>
+                <a:lumMod val="103000"/>
+              </a:schemeClr>
+            </a:gs>
+            <a:gs pos="100000">
+              <a:schemeClr val="phClr">
+                <a:shade val="63000"/>
+                <a:satMod val="120000"/>
+              </a:schemeClr>
+            </a:gs>
+          </a:gsLst>
+          <a:lin ang="5400000" scaled="0"/>
+        </a:gradFill>
+      </a:bgFillStyleLst>
+    </a:fmtScheme>
+  </a:themeElements>
+  <a:objectDefaults>
+    <a:lnDef>
+      <a:spPr/>
+      <a:bodyPr/>
+      <a:lstStyle/>
+      <a:style>
+        <a:lnRef idx="2">
+          <a:schemeClr val="accent1"/>
+        </a:lnRef>
+        <a:fillRef idx="0">
+          <a:schemeClr val="accent1"/>
+        </a:fillRef>
+        <a:effectRef idx="1">
+          <a:schemeClr val="accent1"/>
+        </a:effectRef>
+        <a:fontRef idx="minor">
+          <a:schemeClr val="tx1"/>
+        </a:fontRef>
+      </a:style>
+    </a:lnDef>
+  </a:objectDefaults>
+  <a:extraClrSchemeLst/>
+  <a:extLst>
+    <a:ext uri="{05A4C25C-085E-4340-85A3-A5531E510DB2}">
+      <thm15:themeFamily xmlns:thm15="http://schemas.microsoft.com/office/thememl/2012/main" name="Office Theme" id="{2E142A2C-CD16-42D6-873A-C26D2A0506FA}" vid="{1BDDFF52-6CD6-40A5-AB3C-68EB2F1E4D0A}"/>
+    </a:ext>
+  </a:extLst>
+</a:theme>
 </file>
</xml_diff>